<commit_message>
Update paper and slides with 2x2 results and improved literature positioning
- Add 2x2 comparison slide (s23b): FT×SE interaction showing SE harm shrinks after FT (+0.027→+0.007)
- Add conclusion point (5) summarizing 2x2 finding to slides summary
- Paper: add supplementary 2x2 paragraph in sec 3.4 and point (5) in conclusion
- Rewrite introduction to properly situate within broader SE→ASR paradox literature
  (Ochiai TASLP 2024, Mawalim Interspeech 2024, general noisy environments)
- Strengthen discussion: contrast domain-matched SE (SE-conformer CER 84.4→24.4%) vs
  domain-mismatched GTCRN (CER worsens) to support artifact error framework
- Update references: add TAPS paper (arXiv:2502.11478) and BAF-Net (Interspeech 2025)

Co-Authored-By: Claude Sonnet 4.6 <noreply@anthropic.com>
</commit_message>
<xml_diff>
--- a/results/slides.pptx
+++ b/results/slides.pptx
@@ -32,6 +32,7 @@
     <p:sldId id="280" r:id="rId31"/>
     <p:sldId id="281" r:id="rId32"/>
     <p:sldId id="282" r:id="rId33"/>
+    <p:sldId id="283" r:id="rId34"/>
   </p:sldIdLst>
   <p:sldSz cx="12188952" cy="6858000" type="screen4x3"/>
   <p:notesSz cx="6858000" cy="9144000"/>
@@ -3376,7 +3377,7 @@
                   <a:srgbClr val="1A237E"/>
                 </a:solidFill>
               </a:rPr>
-              <a:t>1 / 25</a:t>
+              <a:t>1 / 28</a:t>
             </a:r>
           </a:p>
         </p:txBody>
@@ -4552,7 +4553,7 @@
                   <a:srgbClr val="1A237E"/>
                 </a:solidFill>
               </a:rPr>
-              <a:t>10 / 25</a:t>
+              <a:t>10 / 28</a:t>
             </a:r>
           </a:p>
         </p:txBody>
@@ -5440,7 +5441,7 @@
                   <a:srgbClr val="1A237E"/>
                 </a:solidFill>
               </a:rPr>
-              <a:t>11 / 25</a:t>
+              <a:t>11 / 28</a:t>
             </a:r>
           </a:p>
         </p:txBody>
@@ -6348,7 +6349,7 @@
                   <a:srgbClr val="1A237E"/>
                 </a:solidFill>
               </a:rPr>
-              <a:t>12 / 25</a:t>
+              <a:t>12 / 28</a:t>
             </a:r>
           </a:p>
         </p:txBody>
@@ -7158,7 +7159,7 @@
                   <a:srgbClr val="1A237E"/>
                 </a:solidFill>
               </a:rPr>
-              <a:t>13 / 25</a:t>
+              <a:t>13 / 28</a:t>
             </a:r>
           </a:p>
         </p:txBody>
@@ -7534,7 +7535,7 @@
                   <a:srgbClr val="1A237E"/>
                 </a:solidFill>
               </a:rPr>
-              <a:t>14 / 25</a:t>
+              <a:t>14 / 28</a:t>
             </a:r>
           </a:p>
         </p:txBody>
@@ -9690,7 +9691,7 @@
                   <a:srgbClr val="1A237E"/>
                 </a:solidFill>
               </a:rPr>
-              <a:t>15 / 25</a:t>
+              <a:t>15 / 28</a:t>
             </a:r>
           </a:p>
         </p:txBody>
@@ -10308,7 +10309,7 @@
                   <a:srgbClr val="1A237E"/>
                 </a:solidFill>
               </a:rPr>
-              <a:t>16 / 25</a:t>
+              <a:t>16 / 28</a:t>
             </a:r>
           </a:p>
         </p:txBody>
@@ -10831,7 +10832,7 @@
                   <a:srgbClr val="1A237E"/>
                 </a:solidFill>
               </a:rPr>
-              <a:t>17 / 25</a:t>
+              <a:t>17 / 28</a:t>
             </a:r>
           </a:p>
         </p:txBody>
@@ -11603,7 +11604,7 @@
                   <a:srgbClr val="1A237E"/>
                 </a:solidFill>
               </a:rPr>
-              <a:t>18 / 25</a:t>
+              <a:t>18 / 28</a:t>
             </a:r>
           </a:p>
         </p:txBody>
@@ -12004,7 +12005,7 @@
                   <a:srgbClr val="1A237E"/>
                 </a:solidFill>
               </a:rPr>
-              <a:t>19 / 25</a:t>
+              <a:t>19 / 28</a:t>
             </a:r>
           </a:p>
         </p:txBody>
@@ -13064,7 +13065,7 @@
                   <a:srgbClr val="1A237E"/>
                 </a:solidFill>
               </a:rPr>
-              <a:t>2 / 25</a:t>
+              <a:t>2 / 28</a:t>
             </a:r>
           </a:p>
         </p:txBody>
@@ -13852,7 +13853,7 @@
                   <a:srgbClr val="1A237E"/>
                 </a:solidFill>
               </a:rPr>
-              <a:t>20 / 25</a:t>
+              <a:t>20 / 28</a:t>
             </a:r>
           </a:p>
         </p:txBody>
@@ -14462,7 +14463,7 @@
                   <a:srgbClr val="1A237E"/>
                 </a:solidFill>
               </a:rPr>
-              <a:t>21 / 25</a:t>
+              <a:t>21 / 28</a:t>
             </a:r>
           </a:p>
         </p:txBody>
@@ -14894,7 +14895,7 @@
                   <a:srgbClr val="1A237E"/>
                 </a:solidFill>
               </a:rPr>
-              <a:t>22 / 25</a:t>
+              <a:t>22 / 28</a:t>
             </a:r>
           </a:p>
         </p:txBody>
@@ -15544,7 +15545,7 @@
                   <a:srgbClr val="1A237E"/>
                 </a:solidFill>
               </a:rPr>
-              <a:t>23 / 25</a:t>
+              <a:t>23 / 28</a:t>
             </a:r>
           </a:p>
         </p:txBody>
@@ -15639,7 +15640,7 @@
                   <a:srgbClr val="FFFFFF"/>
                 </a:solidFill>
               </a:rPr>
-              <a:t>まとめ</a:t>
+              <a:t>補足：2×2 比較（ASRモデル × SE）</a:t>
             </a:r>
           </a:p>
         </p:txBody>
@@ -15652,8 +15653,8 @@
         </p:nvSpPr>
         <p:spPr>
           <a:xfrm>
-            <a:off x="365760" y="1463040"/>
-            <a:ext cx="11430000" cy="502920"/>
+            <a:off x="365760" y="868680"/>
+            <a:ext cx="11430000" cy="365760"/>
           </a:xfrm>
           <a:prstGeom prst="rect">
             <a:avLst/>
@@ -15668,12 +15669,12 @@
           <a:p>
             <a:pPr algn="l"/>
             <a:r>
-              <a:rPr sz="1700" b="0">
-                <a:solidFill>
-                  <a:srgbClr val="212121"/>
-                </a:solidFill>
-              </a:rPr>
-              <a:t>喉マイク音声に対するSEの効果と、ASRモデルのドメイン適応効果を定量評価した。</a:t>
+              <a:rPr sz="1400" b="0">
+                <a:solidFill>
+                  <a:srgbClr val="BBDEFB"/>
+                </a:solidFill>
+              </a:rPr>
+              <a:t>FT後もSEは有害—ただし悪影響は縮小</a:t>
             </a:r>
           </a:p>
         </p:txBody>
@@ -15686,14 +15687,14 @@
         </p:nvSpPr>
         <p:spPr>
           <a:xfrm>
-            <a:off x="365760" y="2103120"/>
-            <a:ext cx="11430000" cy="749808"/>
+            <a:off x="365760" y="1508760"/>
+            <a:ext cx="2743200" cy="777240"/>
           </a:xfrm>
           <a:prstGeom prst="rect">
             <a:avLst/>
           </a:prstGeom>
           <a:solidFill>
-            <a:srgbClr val="F5F5F5"/>
+            <a:srgbClr val="1A237E"/>
           </a:solidFill>
           <a:ln>
             <a:noFill/>
@@ -15729,82 +15730,48 @@
         </p:nvSpPr>
         <p:spPr>
           <a:xfrm>
-            <a:off x="502920" y="2249424"/>
-            <a:ext cx="731520" cy="411480"/>
-          </a:xfrm>
-          <a:prstGeom prst="rect">
-            <a:avLst/>
-          </a:prstGeom>
-          <a:noFill/>
-        </p:spPr>
-        <p:txBody>
-          <a:bodyPr wrap="square">
-            <a:spAutoFit/>
-          </a:bodyPr>
-          <a:lstStyle/>
-          <a:p>
-            <a:pPr algn="l"/>
-            <a:r>
-              <a:rPr sz="1500" b="1">
-                <a:solidFill>
-                  <a:srgbClr val="C62828"/>
-                </a:solidFill>
-              </a:rPr>
-              <a:t>（1）</a:t>
-            </a:r>
-          </a:p>
-        </p:txBody>
-      </p:sp>
-      <p:sp>
-        <p:nvSpPr>
-          <p:cNvPr id="7" name="TextBox 6"/>
-          <p:cNvSpPr txBox="1"/>
-          <p:nvPr/>
-        </p:nvSpPr>
-        <p:spPr>
-          <a:xfrm>
-            <a:off x="1143000" y="2249424"/>
-            <a:ext cx="10424160" cy="411480"/>
-          </a:xfrm>
-          <a:prstGeom prst="rect">
-            <a:avLst/>
-          </a:prstGeom>
-          <a:noFill/>
-        </p:spPr>
-        <p:txBody>
-          <a:bodyPr wrap="square">
-            <a:spAutoFit/>
-          </a:bodyPr>
-          <a:lstStyle/>
-          <a:p>
-            <a:pPr algn="l"/>
-            <a:r>
-              <a:rPr sz="1500" b="0">
-                <a:solidFill>
-                  <a:srgbClr val="212121"/>
-                </a:solidFill>
-              </a:rPr>
-              <a:t>DSP-onlyおよびGTCRNは全ノイズ条件でCERを有意に悪化させる（30検定中26件 p&lt;0.05）</a:t>
-            </a:r>
-          </a:p>
-        </p:txBody>
-      </p:sp>
-      <p:sp>
-        <p:nvSpPr>
-          <p:cNvPr id="8" name="Rectangle 7"/>
+            <a:off x="411480" y="1709928"/>
+            <a:ext cx="2651760" cy="365760"/>
+          </a:xfrm>
+          <a:prstGeom prst="rect">
+            <a:avLst/>
+          </a:prstGeom>
+          <a:noFill/>
+        </p:spPr>
+        <p:txBody>
+          <a:bodyPr wrap="square">
+            <a:spAutoFit/>
+          </a:bodyPr>
+          <a:lstStyle/>
+          <a:p>
+            <a:pPr algn="ctr"/>
+            <a:r>
+              <a:rPr sz="1600" b="1">
+                <a:solidFill>
+                  <a:srgbClr val="FFFFFF"/>
+                </a:solidFill>
+              </a:rPr>
+              <a:t/>
+            </a:r>
+          </a:p>
+        </p:txBody>
+      </p:sp>
+      <p:sp>
+        <p:nvSpPr>
+          <p:cNvPr id="7" name="Rectangle 6"/>
           <p:cNvSpPr/>
           <p:nvPr/>
         </p:nvSpPr>
         <p:spPr>
           <a:xfrm>
-            <a:off x="365760" y="2971800"/>
-            <a:ext cx="11430000" cy="749808"/>
+            <a:off x="3200400" y="1508760"/>
+            <a:ext cx="3931920" cy="777240"/>
           </a:xfrm>
           <a:prstGeom prst="rect">
             <a:avLst/>
           </a:prstGeom>
           <a:solidFill>
-            <a:srgbClr val="F5F5F5"/>
+            <a:srgbClr val="1A237E"/>
           </a:solidFill>
           <a:ln>
             <a:noFill/>
@@ -15834,88 +15801,54 @@
       </p:sp>
       <p:sp>
         <p:nvSpPr>
-          <p:cNvPr id="9" name="TextBox 8"/>
-          <p:cNvSpPr txBox="1"/>
-          <p:nvPr/>
-        </p:nvSpPr>
-        <p:spPr>
-          <a:xfrm>
-            <a:off x="502920" y="3118104"/>
-            <a:ext cx="731520" cy="411480"/>
-          </a:xfrm>
-          <a:prstGeom prst="rect">
-            <a:avLst/>
-          </a:prstGeom>
-          <a:noFill/>
-        </p:spPr>
-        <p:txBody>
-          <a:bodyPr wrap="square">
-            <a:spAutoFit/>
-          </a:bodyPr>
-          <a:lstStyle/>
-          <a:p>
-            <a:pPr algn="l"/>
-            <a:r>
-              <a:rPr sz="1500" b="1">
-                <a:solidFill>
-                  <a:srgbClr val="FF9800"/>
-                </a:solidFill>
-              </a:rPr>
-              <a:t>（2）</a:t>
-            </a:r>
-          </a:p>
-        </p:txBody>
-      </p:sp>
-      <p:sp>
-        <p:nvSpPr>
-          <p:cNvPr id="10" name="TextBox 9"/>
-          <p:cNvSpPr txBox="1"/>
-          <p:nvPr/>
-        </p:nvSpPr>
-        <p:spPr>
-          <a:xfrm>
-            <a:off x="1143000" y="3118104"/>
-            <a:ext cx="10424160" cy="411480"/>
-          </a:xfrm>
-          <a:prstGeom prst="rect">
-            <a:avLst/>
-          </a:prstGeom>
-          <a:noFill/>
-        </p:spPr>
-        <p:txBody>
-          <a:bodyPr wrap="square">
-            <a:spAutoFit/>
-          </a:bodyPr>
-          <a:lstStyle/>
-          <a:p>
-            <a:pPr algn="l"/>
-            <a:r>
-              <a:rPr sz="1500" b="0">
-                <a:solidFill>
-                  <a:srgbClr val="212121"/>
-                </a:solidFill>
-              </a:rPr>
-              <a:t>GTCRNはSTOI・PESQを改善しながらCERを悪化させる三重パラドックスが全ノイズ条件で観測された</a:t>
-            </a:r>
-          </a:p>
-        </p:txBody>
-      </p:sp>
-      <p:sp>
-        <p:nvSpPr>
-          <p:cNvPr id="11" name="Rectangle 10"/>
+          <p:cNvPr id="8" name="TextBox 7"/>
+          <p:cNvSpPr txBox="1"/>
+          <p:nvPr/>
+        </p:nvSpPr>
+        <p:spPr>
+          <a:xfrm>
+            <a:off x="3246120" y="1709928"/>
+            <a:ext cx="3840480" cy="365760"/>
+          </a:xfrm>
+          <a:prstGeom prst="rect">
+            <a:avLst/>
+          </a:prstGeom>
+          <a:noFill/>
+        </p:spPr>
+        <p:txBody>
+          <a:bodyPr wrap="square">
+            <a:spAutoFit/>
+          </a:bodyPr>
+          <a:lstStyle/>
+          <a:p>
+            <a:pPr algn="ctr"/>
+            <a:r>
+              <a:rPr sz="1600" b="1">
+                <a:solidFill>
+                  <a:srgbClr val="FFFFFF"/>
+                </a:solidFill>
+              </a:rPr>
+              <a:t>No SE</a:t>
+            </a:r>
+          </a:p>
+        </p:txBody>
+      </p:sp>
+      <p:sp>
+        <p:nvSpPr>
+          <p:cNvPr id="9" name="Rectangle 8"/>
           <p:cNvSpPr/>
           <p:nvPr/>
         </p:nvSpPr>
         <p:spPr>
           <a:xfrm>
-            <a:off x="365760" y="3840480"/>
-            <a:ext cx="11430000" cy="749808"/>
+            <a:off x="7315200" y="1508760"/>
+            <a:ext cx="4114800" cy="777240"/>
           </a:xfrm>
           <a:prstGeom prst="rect">
             <a:avLst/>
           </a:prstGeom>
           <a:solidFill>
-            <a:srgbClr val="F5F5F5"/>
+            <a:srgbClr val="1A237E"/>
           </a:solidFill>
           <a:ln>
             <a:noFill/>
@@ -15945,88 +15878,54 @@
       </p:sp>
       <p:sp>
         <p:nvSpPr>
-          <p:cNvPr id="12" name="TextBox 11"/>
-          <p:cNvSpPr txBox="1"/>
-          <p:nvPr/>
-        </p:nvSpPr>
-        <p:spPr>
-          <a:xfrm>
-            <a:off x="502920" y="3986784"/>
-            <a:ext cx="731520" cy="411480"/>
-          </a:xfrm>
-          <a:prstGeom prst="rect">
-            <a:avLst/>
-          </a:prstGeom>
-          <a:noFill/>
-        </p:spPr>
-        <p:txBody>
-          <a:bodyPr wrap="square">
-            <a:spAutoFit/>
-          </a:bodyPr>
-          <a:lstStyle/>
-          <a:p>
-            <a:pPr algn="l"/>
-            <a:r>
-              <a:rPr sz="1500" b="1">
-                <a:solidFill>
-                  <a:srgbClr val="FF9800"/>
-                </a:solidFill>
-              </a:rPr>
-              <a:t>（3）</a:t>
-            </a:r>
-          </a:p>
-        </p:txBody>
-      </p:sp>
-      <p:sp>
-        <p:nvSpPr>
-          <p:cNvPr id="13" name="TextBox 12"/>
-          <p:cNvSpPr txBox="1"/>
-          <p:nvPr/>
-        </p:nvSpPr>
-        <p:spPr>
-          <a:xfrm>
-            <a:off x="1143000" y="3986784"/>
-            <a:ext cx="10424160" cy="411480"/>
-          </a:xfrm>
-          <a:prstGeom prst="rect">
-            <a:avLst/>
-          </a:prstGeom>
-          <a:noFill/>
-        </p:spPr>
-        <p:txBody>
-          <a:bodyPr wrap="square">
-            <a:spAutoFit/>
-          </a:bodyPr>
-          <a:lstStyle/>
-          <a:p>
-            <a:pPr algn="l"/>
-            <a:r>
-              <a:rPr sz="1500" b="0">
-                <a:solidFill>
-                  <a:srgbClr val="212121"/>
-                </a:solidFill>
-              </a:rPr>
-              <a:t>DSP-onlyは3指標すべてを悪化させ、喉マイクには不適切な前処理である</a:t>
-            </a:r>
-          </a:p>
-        </p:txBody>
-      </p:sp>
-      <p:sp>
-        <p:nvSpPr>
-          <p:cNvPr id="14" name="Rectangle 13"/>
+          <p:cNvPr id="10" name="TextBox 9"/>
+          <p:cNvSpPr txBox="1"/>
+          <p:nvPr/>
+        </p:nvSpPr>
+        <p:spPr>
+          <a:xfrm>
+            <a:off x="7360920" y="1709928"/>
+            <a:ext cx="4023360" cy="365760"/>
+          </a:xfrm>
+          <a:prstGeom prst="rect">
+            <a:avLst/>
+          </a:prstGeom>
+          <a:noFill/>
+        </p:spPr>
+        <p:txBody>
+          <a:bodyPr wrap="square">
+            <a:spAutoFit/>
+          </a:bodyPr>
+          <a:lstStyle/>
+          <a:p>
+            <a:pPr algn="ctr"/>
+            <a:r>
+              <a:rPr sz="1600" b="1">
+                <a:solidFill>
+                  <a:srgbClr val="FFFFFF"/>
+                </a:solidFill>
+              </a:rPr>
+              <a:t>GTCRN SE</a:t>
+            </a:r>
+          </a:p>
+        </p:txBody>
+      </p:sp>
+      <p:sp>
+        <p:nvSpPr>
+          <p:cNvPr id="11" name="Rectangle 10"/>
           <p:cNvSpPr/>
           <p:nvPr/>
         </p:nvSpPr>
         <p:spPr>
           <a:xfrm>
-            <a:off x="365760" y="4709160"/>
-            <a:ext cx="11430000" cy="749808"/>
+            <a:off x="365760" y="2377440"/>
+            <a:ext cx="2743200" cy="777240"/>
           </a:xfrm>
           <a:prstGeom prst="rect">
             <a:avLst/>
           </a:prstGeom>
           <a:solidFill>
-            <a:srgbClr val="F5F5F5"/>
+            <a:srgbClr val="1A237E"/>
           </a:solidFill>
           <a:ln>
             <a:noFill/>
@@ -16056,14 +15955,467 @@
       </p:sp>
       <p:sp>
         <p:nvSpPr>
-          <p:cNvPr id="15" name="TextBox 14"/>
-          <p:cNvSpPr txBox="1"/>
-          <p:nvPr/>
-        </p:nvSpPr>
-        <p:spPr>
-          <a:xfrm>
-            <a:off x="502920" y="4855464"/>
-            <a:ext cx="731520" cy="411480"/>
+          <p:cNvPr id="12" name="TextBox 11"/>
+          <p:cNvSpPr txBox="1"/>
+          <p:nvPr/>
+        </p:nvSpPr>
+        <p:spPr>
+          <a:xfrm>
+            <a:off x="411480" y="2560320"/>
+            <a:ext cx="2651760" cy="457200"/>
+          </a:xfrm>
+          <a:prstGeom prst="rect">
+            <a:avLst/>
+          </a:prstGeom>
+          <a:noFill/>
+        </p:spPr>
+        <p:txBody>
+          <a:bodyPr wrap="square">
+            <a:spAutoFit/>
+          </a:bodyPr>
+          <a:lstStyle/>
+          <a:p>
+            <a:pPr algn="ctr"/>
+            <a:r>
+              <a:rPr sz="1500" b="1">
+                <a:solidFill>
+                  <a:srgbClr val="FFFFFF"/>
+                </a:solidFill>
+              </a:rPr>
+              <a:t>未学習 Whisper</a:t>
+            </a:r>
+          </a:p>
+        </p:txBody>
+      </p:sp>
+      <p:sp>
+        <p:nvSpPr>
+          <p:cNvPr id="13" name="Rectangle 12"/>
+          <p:cNvSpPr/>
+          <p:nvPr/>
+        </p:nvSpPr>
+        <p:spPr>
+          <a:xfrm>
+            <a:off x="3200400" y="2377440"/>
+            <a:ext cx="3931920" cy="777240"/>
+          </a:xfrm>
+          <a:prstGeom prst="rect">
+            <a:avLst/>
+          </a:prstGeom>
+          <a:solidFill>
+            <a:srgbClr val="E3F2FD"/>
+          </a:solidFill>
+          <a:ln>
+            <a:noFill/>
+          </a:ln>
+        </p:spPr>
+        <p:style>
+          <a:lnRef idx="1">
+            <a:schemeClr val="accent1"/>
+          </a:lnRef>
+          <a:fillRef idx="3">
+            <a:schemeClr val="accent1"/>
+          </a:fillRef>
+          <a:effectRef idx="2">
+            <a:schemeClr val="accent1"/>
+          </a:effectRef>
+          <a:fontRef idx="minor">
+            <a:schemeClr val="lt1"/>
+          </a:fontRef>
+        </p:style>
+        <p:txBody>
+          <a:bodyPr rtlCol="0" anchor="ctr"/>
+          <a:lstStyle/>
+          <a:p>
+            <a:pPr algn="ctr"/>
+          </a:p>
+        </p:txBody>
+      </p:sp>
+      <p:sp>
+        <p:nvSpPr>
+          <p:cNvPr id="14" name="TextBox 13"/>
+          <p:cNvSpPr txBox="1"/>
+          <p:nvPr/>
+        </p:nvSpPr>
+        <p:spPr>
+          <a:xfrm>
+            <a:off x="3246120" y="2560320"/>
+            <a:ext cx="3840480" cy="457200"/>
+          </a:xfrm>
+          <a:prstGeom prst="rect">
+            <a:avLst/>
+          </a:prstGeom>
+          <a:noFill/>
+        </p:spPr>
+        <p:txBody>
+          <a:bodyPr wrap="square">
+            <a:spAutoFit/>
+          </a:bodyPr>
+          <a:lstStyle/>
+          <a:p>
+            <a:pPr algn="ctr"/>
+            <a:r>
+              <a:rPr sz="2000" b="0">
+                <a:solidFill>
+                  <a:srgbClr val="212121"/>
+                </a:solidFill>
+              </a:rPr>
+              <a:t>0.269  [A]</a:t>
+            </a:r>
+          </a:p>
+        </p:txBody>
+      </p:sp>
+      <p:sp>
+        <p:nvSpPr>
+          <p:cNvPr id="15" name="Rectangle 14"/>
+          <p:cNvSpPr/>
+          <p:nvPr/>
+        </p:nvSpPr>
+        <p:spPr>
+          <a:xfrm>
+            <a:off x="7315200" y="2377440"/>
+            <a:ext cx="4114800" cy="777240"/>
+          </a:xfrm>
+          <a:prstGeom prst="rect">
+            <a:avLst/>
+          </a:prstGeom>
+          <a:solidFill>
+            <a:srgbClr val="FFEBEE"/>
+          </a:solidFill>
+          <a:ln>
+            <a:noFill/>
+          </a:ln>
+        </p:spPr>
+        <p:style>
+          <a:lnRef idx="1">
+            <a:schemeClr val="accent1"/>
+          </a:lnRef>
+          <a:fillRef idx="3">
+            <a:schemeClr val="accent1"/>
+          </a:fillRef>
+          <a:effectRef idx="2">
+            <a:schemeClr val="accent1"/>
+          </a:effectRef>
+          <a:fontRef idx="minor">
+            <a:schemeClr val="lt1"/>
+          </a:fontRef>
+        </p:style>
+        <p:txBody>
+          <a:bodyPr rtlCol="0" anchor="ctr"/>
+          <a:lstStyle/>
+          <a:p>
+            <a:pPr algn="ctr"/>
+          </a:p>
+        </p:txBody>
+      </p:sp>
+      <p:sp>
+        <p:nvSpPr>
+          <p:cNvPr id="16" name="TextBox 15"/>
+          <p:cNvSpPr txBox="1"/>
+          <p:nvPr/>
+        </p:nvSpPr>
+        <p:spPr>
+          <a:xfrm>
+            <a:off x="7360920" y="2560320"/>
+            <a:ext cx="4023360" cy="457200"/>
+          </a:xfrm>
+          <a:prstGeom prst="rect">
+            <a:avLst/>
+          </a:prstGeom>
+          <a:noFill/>
+        </p:spPr>
+        <p:txBody>
+          <a:bodyPr wrap="square">
+            <a:spAutoFit/>
+          </a:bodyPr>
+          <a:lstStyle/>
+          <a:p>
+            <a:pPr algn="ctr"/>
+            <a:r>
+              <a:rPr sz="2000" b="0">
+                <a:solidFill>
+                  <a:srgbClr val="212121"/>
+                </a:solidFill>
+              </a:rPr>
+              <a:t>0.296  [B]  (+0.027)</a:t>
+            </a:r>
+          </a:p>
+        </p:txBody>
+      </p:sp>
+      <p:sp>
+        <p:nvSpPr>
+          <p:cNvPr id="17" name="Rectangle 16"/>
+          <p:cNvSpPr/>
+          <p:nvPr/>
+        </p:nvSpPr>
+        <p:spPr>
+          <a:xfrm>
+            <a:off x="365760" y="3246120"/>
+            <a:ext cx="2743200" cy="777240"/>
+          </a:xfrm>
+          <a:prstGeom prst="rect">
+            <a:avLst/>
+          </a:prstGeom>
+          <a:solidFill>
+            <a:srgbClr val="1A237E"/>
+          </a:solidFill>
+          <a:ln>
+            <a:noFill/>
+          </a:ln>
+        </p:spPr>
+        <p:style>
+          <a:lnRef idx="1">
+            <a:schemeClr val="accent1"/>
+          </a:lnRef>
+          <a:fillRef idx="3">
+            <a:schemeClr val="accent1"/>
+          </a:fillRef>
+          <a:effectRef idx="2">
+            <a:schemeClr val="accent1"/>
+          </a:effectRef>
+          <a:fontRef idx="minor">
+            <a:schemeClr val="lt1"/>
+          </a:fontRef>
+        </p:style>
+        <p:txBody>
+          <a:bodyPr rtlCol="0" anchor="ctr"/>
+          <a:lstStyle/>
+          <a:p>
+            <a:pPr algn="ctr"/>
+          </a:p>
+        </p:txBody>
+      </p:sp>
+      <p:sp>
+        <p:nvSpPr>
+          <p:cNvPr id="18" name="TextBox 17"/>
+          <p:cNvSpPr txBox="1"/>
+          <p:nvPr/>
+        </p:nvSpPr>
+        <p:spPr>
+          <a:xfrm>
+            <a:off x="411480" y="3429000"/>
+            <a:ext cx="2651760" cy="457200"/>
+          </a:xfrm>
+          <a:prstGeom prst="rect">
+            <a:avLst/>
+          </a:prstGeom>
+          <a:noFill/>
+        </p:spPr>
+        <p:txBody>
+          <a:bodyPr wrap="square">
+            <a:spAutoFit/>
+          </a:bodyPr>
+          <a:lstStyle/>
+          <a:p>
+            <a:pPr algn="ctr"/>
+            <a:r>
+              <a:rPr sz="1500" b="1">
+                <a:solidFill>
+                  <a:srgbClr val="FFFFFF"/>
+                </a:solidFill>
+              </a:rPr>
+              <a:t>FT済み Whisper</a:t>
+            </a:r>
+          </a:p>
+        </p:txBody>
+      </p:sp>
+      <p:sp>
+        <p:nvSpPr>
+          <p:cNvPr id="19" name="Rectangle 18"/>
+          <p:cNvSpPr/>
+          <p:nvPr/>
+        </p:nvSpPr>
+        <p:spPr>
+          <a:xfrm>
+            <a:off x="3200400" y="3246120"/>
+            <a:ext cx="3931920" cy="777240"/>
+          </a:xfrm>
+          <a:prstGeom prst="rect">
+            <a:avLst/>
+          </a:prstGeom>
+          <a:solidFill>
+            <a:srgbClr val="C8E6C9"/>
+          </a:solidFill>
+          <a:ln>
+            <a:noFill/>
+          </a:ln>
+        </p:spPr>
+        <p:style>
+          <a:lnRef idx="1">
+            <a:schemeClr val="accent1"/>
+          </a:lnRef>
+          <a:fillRef idx="3">
+            <a:schemeClr val="accent1"/>
+          </a:fillRef>
+          <a:effectRef idx="2">
+            <a:schemeClr val="accent1"/>
+          </a:effectRef>
+          <a:fontRef idx="minor">
+            <a:schemeClr val="lt1"/>
+          </a:fontRef>
+        </p:style>
+        <p:txBody>
+          <a:bodyPr rtlCol="0" anchor="ctr"/>
+          <a:lstStyle/>
+          <a:p>
+            <a:pPr algn="ctr"/>
+          </a:p>
+        </p:txBody>
+      </p:sp>
+      <p:sp>
+        <p:nvSpPr>
+          <p:cNvPr id="20" name="TextBox 19"/>
+          <p:cNvSpPr txBox="1"/>
+          <p:nvPr/>
+        </p:nvSpPr>
+        <p:spPr>
+          <a:xfrm>
+            <a:off x="3246120" y="3429000"/>
+            <a:ext cx="3840480" cy="457200"/>
+          </a:xfrm>
+          <a:prstGeom prst="rect">
+            <a:avLst/>
+          </a:prstGeom>
+          <a:noFill/>
+        </p:spPr>
+        <p:txBody>
+          <a:bodyPr wrap="square">
+            <a:spAutoFit/>
+          </a:bodyPr>
+          <a:lstStyle/>
+          <a:p>
+            <a:pPr algn="ctr"/>
+            <a:r>
+              <a:rPr sz="2000" b="0">
+                <a:solidFill>
+                  <a:srgbClr val="212121"/>
+                </a:solidFill>
+              </a:rPr>
+              <a:t>0.095  [C]</a:t>
+            </a:r>
+          </a:p>
+        </p:txBody>
+      </p:sp>
+      <p:sp>
+        <p:nvSpPr>
+          <p:cNvPr id="21" name="Rectangle 20"/>
+          <p:cNvSpPr/>
+          <p:nvPr/>
+        </p:nvSpPr>
+        <p:spPr>
+          <a:xfrm>
+            <a:off x="7315200" y="3246120"/>
+            <a:ext cx="4114800" cy="777240"/>
+          </a:xfrm>
+          <a:prstGeom prst="rect">
+            <a:avLst/>
+          </a:prstGeom>
+          <a:solidFill>
+            <a:srgbClr val="FFF9C4"/>
+          </a:solidFill>
+          <a:ln>
+            <a:noFill/>
+          </a:ln>
+        </p:spPr>
+        <p:style>
+          <a:lnRef idx="1">
+            <a:schemeClr val="accent1"/>
+          </a:lnRef>
+          <a:fillRef idx="3">
+            <a:schemeClr val="accent1"/>
+          </a:fillRef>
+          <a:effectRef idx="2">
+            <a:schemeClr val="accent1"/>
+          </a:effectRef>
+          <a:fontRef idx="minor">
+            <a:schemeClr val="lt1"/>
+          </a:fontRef>
+        </p:style>
+        <p:txBody>
+          <a:bodyPr rtlCol="0" anchor="ctr"/>
+          <a:lstStyle/>
+          <a:p>
+            <a:pPr algn="ctr"/>
+          </a:p>
+        </p:txBody>
+      </p:sp>
+      <p:sp>
+        <p:nvSpPr>
+          <p:cNvPr id="22" name="TextBox 21"/>
+          <p:cNvSpPr txBox="1"/>
+          <p:nvPr/>
+        </p:nvSpPr>
+        <p:spPr>
+          <a:xfrm>
+            <a:off x="7360920" y="3429000"/>
+            <a:ext cx="4023360" cy="457200"/>
+          </a:xfrm>
+          <a:prstGeom prst="rect">
+            <a:avLst/>
+          </a:prstGeom>
+          <a:noFill/>
+        </p:spPr>
+        <p:txBody>
+          <a:bodyPr wrap="square">
+            <a:spAutoFit/>
+          </a:bodyPr>
+          <a:lstStyle/>
+          <a:p>
+            <a:pPr algn="ctr"/>
+            <a:r>
+              <a:rPr sz="2000" b="0">
+                <a:solidFill>
+                  <a:srgbClr val="212121"/>
+                </a:solidFill>
+              </a:rPr>
+              <a:t>0.1015 [D]  (+0.007)</a:t>
+            </a:r>
+          </a:p>
+        </p:txBody>
+      </p:sp>
+      <p:sp>
+        <p:nvSpPr>
+          <p:cNvPr id="23" name="TextBox 22"/>
+          <p:cNvSpPr txBox="1"/>
+          <p:nvPr/>
+        </p:nvSpPr>
+        <p:spPr>
+          <a:xfrm>
+            <a:off x="7452360" y="2331720"/>
+            <a:ext cx="3931920" cy="320040"/>
+          </a:xfrm>
+          <a:prstGeom prst="rect">
+            <a:avLst/>
+          </a:prstGeom>
+          <a:noFill/>
+        </p:spPr>
+        <p:txBody>
+          <a:bodyPr wrap="square">
+            <a:spAutoFit/>
+          </a:bodyPr>
+          <a:lstStyle/>
+          <a:p>
+            <a:pPr algn="ctr"/>
+            <a:r>
+              <a:rPr sz="1200" b="0">
+                <a:solidFill>
+                  <a:srgbClr val="78909C"/>
+                </a:solidFill>
+              </a:rPr>
+              <a:t>▼ SE悪化幅</a:t>
+            </a:r>
+          </a:p>
+        </p:txBody>
+      </p:sp>
+      <p:sp>
+        <p:nvSpPr>
+          <p:cNvPr id="24" name="TextBox 23"/>
+          <p:cNvSpPr txBox="1"/>
+          <p:nvPr/>
+        </p:nvSpPr>
+        <p:spPr>
+          <a:xfrm>
+            <a:off x="7315200" y="4114800"/>
+            <a:ext cx="4572000" cy="457200"/>
           </a:xfrm>
           <a:prstGeom prst="rect">
             <a:avLst/>
@@ -16078,53 +16430,96 @@
           <a:p>
             <a:pPr algn="l"/>
             <a:r>
-              <a:rPr sz="1500" b="1">
+              <a:rPr sz="1600" b="1">
                 <a:solidFill>
                   <a:srgbClr val="43A047"/>
                 </a:solidFill>
               </a:rPr>
-              <a:t>（4）</a:t>
-            </a:r>
-          </a:p>
-        </p:txBody>
-      </p:sp>
-      <p:sp>
-        <p:nvSpPr>
-          <p:cNvPr id="16" name="TextBox 15"/>
-          <p:cNvSpPr txBox="1"/>
-          <p:nvPr/>
-        </p:nvSpPr>
-        <p:spPr>
-          <a:xfrm>
-            <a:off x="1143000" y="4855464"/>
-            <a:ext cx="10424160" cy="411480"/>
-          </a:xfrm>
-          <a:prstGeom prst="rect">
-            <a:avLst/>
-          </a:prstGeom>
-          <a:noFill/>
-        </p:spPr>
-        <p:txBody>
-          <a:bodyPr wrap="square">
-            <a:spAutoFit/>
-          </a:bodyPr>
-          <a:lstStyle/>
-          <a:p>
-            <a:pPr algn="l"/>
-            <a:r>
-              <a:rPr sz="1500" b="0">
-                <a:solidFill>
-                  <a:srgbClr val="212121"/>
-                </a:solidFill>
-              </a:rPr>
-              <a:t>Whisper smallのFTによりCERが0.269→0.095（64.6%改善）—「ASR側の適応」が音声処理より有効</a:t>
-            </a:r>
-          </a:p>
-        </p:txBody>
-      </p:sp>
-      <p:sp>
-        <p:nvSpPr>
-          <p:cNvPr id="17" name="Rectangle 16"/>
+              <a:t>+0.027 → +0.007 に縮小</a:t>
+            </a:r>
+          </a:p>
+        </p:txBody>
+      </p:sp>
+      <p:sp>
+        <p:nvSpPr>
+          <p:cNvPr id="25" name="Rectangle 24"/>
+          <p:cNvSpPr/>
+          <p:nvPr/>
+        </p:nvSpPr>
+        <p:spPr>
+          <a:xfrm>
+            <a:off x="365760" y="4846320"/>
+            <a:ext cx="11430000" cy="731520"/>
+          </a:xfrm>
+          <a:prstGeom prst="rect">
+            <a:avLst/>
+          </a:prstGeom>
+          <a:solidFill>
+            <a:srgbClr val="FFF9C4"/>
+          </a:solidFill>
+          <a:ln>
+            <a:noFill/>
+          </a:ln>
+        </p:spPr>
+        <p:style>
+          <a:lnRef idx="1">
+            <a:schemeClr val="accent1"/>
+          </a:lnRef>
+          <a:fillRef idx="3">
+            <a:schemeClr val="accent1"/>
+          </a:fillRef>
+          <a:effectRef idx="2">
+            <a:schemeClr val="accent1"/>
+          </a:effectRef>
+          <a:fontRef idx="minor">
+            <a:schemeClr val="lt1"/>
+          </a:fontRef>
+        </p:style>
+        <p:txBody>
+          <a:bodyPr rtlCol="0" anchor="ctr"/>
+          <a:lstStyle/>
+          <a:p>
+            <a:pPr algn="ctr"/>
+          </a:p>
+        </p:txBody>
+      </p:sp>
+      <p:sp>
+        <p:nvSpPr>
+          <p:cNvPr id="26" name="TextBox 25"/>
+          <p:cNvSpPr txBox="1"/>
+          <p:nvPr/>
+        </p:nvSpPr>
+        <p:spPr>
+          <a:xfrm>
+            <a:off x="502920" y="4956048"/>
+            <a:ext cx="11155680" cy="457200"/>
+          </a:xfrm>
+          <a:prstGeom prst="rect">
+            <a:avLst/>
+          </a:prstGeom>
+          <a:noFill/>
+        </p:spPr>
+        <p:txBody>
+          <a:bodyPr wrap="square">
+            <a:spAutoFit/>
+          </a:bodyPr>
+          <a:lstStyle/>
+          <a:p>
+            <a:pPr algn="ctr"/>
+            <a:r>
+              <a:rPr sz="1600" b="1">
+                <a:solidFill>
+                  <a:srgbClr val="1A237E"/>
+                </a:solidFill>
+              </a:rPr>
+              <a:t>FTによりSEの悪影響は縮小するが消えない—SEの適用はFT後も推奨されない</a:t>
+            </a:r>
+          </a:p>
+        </p:txBody>
+      </p:sp>
+      <p:sp>
+        <p:nvSpPr>
+          <p:cNvPr id="27" name="Rectangle 26"/>
           <p:cNvSpPr/>
           <p:nvPr/>
         </p:nvSpPr>
@@ -16167,7 +16562,7 @@
       </p:sp>
       <p:sp>
         <p:nvSpPr>
-          <p:cNvPr id="18" name="TextBox 17"/>
+          <p:cNvPr id="28" name="TextBox 27"/>
           <p:cNvSpPr txBox="1"/>
           <p:nvPr/>
         </p:nvSpPr>
@@ -16194,7 +16589,7 @@
                   <a:srgbClr val="1A237E"/>
                 </a:solidFill>
               </a:rPr>
-              <a:t>24 / 25</a:t>
+              <a:t>24 / 28</a:t>
             </a:r>
           </a:p>
         </p:txBody>
@@ -16289,27 +16684,61 @@
                   <a:srgbClr val="FFFFFF"/>
                 </a:solidFill>
               </a:rPr>
-              <a:t>今後の展望</a:t>
-            </a:r>
-          </a:p>
-        </p:txBody>
-      </p:sp>
-      <p:sp>
-        <p:nvSpPr>
-          <p:cNvPr id="4" name="Rectangle 3"/>
+              <a:t>まとめ</a:t>
+            </a:r>
+          </a:p>
+        </p:txBody>
+      </p:sp>
+      <p:sp>
+        <p:nvSpPr>
+          <p:cNvPr id="4" name="TextBox 3"/>
+          <p:cNvSpPr txBox="1"/>
+          <p:nvPr/>
+        </p:nvSpPr>
+        <p:spPr>
+          <a:xfrm>
+            <a:off x="365760" y="1463040"/>
+            <a:ext cx="11430000" cy="502920"/>
+          </a:xfrm>
+          <a:prstGeom prst="rect">
+            <a:avLst/>
+          </a:prstGeom>
+          <a:noFill/>
+        </p:spPr>
+        <p:txBody>
+          <a:bodyPr wrap="square">
+            <a:spAutoFit/>
+          </a:bodyPr>
+          <a:lstStyle/>
+          <a:p>
+            <a:pPr algn="l"/>
+            <a:r>
+              <a:rPr sz="1700" b="0">
+                <a:solidFill>
+                  <a:srgbClr val="212121"/>
+                </a:solidFill>
+              </a:rPr>
+              <a:t>喉マイク音声に対するSEの効果と、ASRモデルのドメイン適応効果を定量評価した。</a:t>
+            </a:r>
+          </a:p>
+        </p:txBody>
+      </p:sp>
+      <p:sp>
+        <p:nvSpPr>
+          <p:cNvPr id="5" name="Rectangle 4"/>
           <p:cNvSpPr/>
           <p:nvPr/>
         </p:nvSpPr>
         <p:spPr>
           <a:xfrm>
-            <a:off x="365760" y="1463040"/>
-            <a:ext cx="11430000" cy="1463040"/>
+            <a:off x="365760" y="1508760"/>
+            <a:ext cx="11430000" cy="621792"/>
           </a:xfrm>
           <a:prstGeom prst="rect">
             <a:avLst/>
           </a:prstGeom>
           <a:solidFill>
-            <a:srgbClr val="FFEBEE"/>
+            <a:srgbClr val="F5F5F5"/>
           </a:solidFill>
           <a:ln>
             <a:noFill/>
@@ -16339,14 +16768,14 @@
       </p:sp>
       <p:sp>
         <p:nvSpPr>
-          <p:cNvPr id="5" name="TextBox 4"/>
-          <p:cNvSpPr txBox="1"/>
-          <p:nvPr/>
-        </p:nvSpPr>
-        <p:spPr>
-          <a:xfrm>
-            <a:off x="502920" y="1508760"/>
-            <a:ext cx="2560320" cy="320040"/>
+          <p:cNvPr id="6" name="TextBox 5"/>
+          <p:cNvSpPr txBox="1"/>
+          <p:nvPr/>
+        </p:nvSpPr>
+        <p:spPr>
+          <a:xfrm>
+            <a:off x="502920" y="1600200"/>
+            <a:ext cx="731520" cy="411480"/>
           </a:xfrm>
           <a:prstGeom prst="rect">
             <a:avLst/>
@@ -16361,26 +16790,26 @@
           <a:p>
             <a:pPr algn="l"/>
             <a:r>
-              <a:rPr sz="1100" b="1">
-                <a:solidFill>
-                  <a:srgbClr val="78909C"/>
-                </a:solidFill>
-              </a:rPr>
-              <a:t>優先度：高</a:t>
-            </a:r>
-          </a:p>
-        </p:txBody>
-      </p:sp>
-      <p:sp>
-        <p:nvSpPr>
-          <p:cNvPr id="6" name="TextBox 5"/>
-          <p:cNvSpPr txBox="1"/>
-          <p:nvPr/>
-        </p:nvSpPr>
-        <p:spPr>
-          <a:xfrm>
-            <a:off x="502920" y="1810512"/>
-            <a:ext cx="11064240" cy="384048"/>
+              <a:rPr sz="1400" b="1">
+                <a:solidFill>
+                  <a:srgbClr val="C62828"/>
+                </a:solidFill>
+              </a:rPr>
+              <a:t>（1）</a:t>
+            </a:r>
+          </a:p>
+        </p:txBody>
+      </p:sp>
+      <p:sp>
+        <p:nvSpPr>
+          <p:cNvPr id="7" name="TextBox 6"/>
+          <p:cNvSpPr txBox="1"/>
+          <p:nvPr/>
+        </p:nvSpPr>
+        <p:spPr>
+          <a:xfrm>
+            <a:off x="1143000" y="1600200"/>
+            <a:ext cx="10424160" cy="411480"/>
           </a:xfrm>
           <a:prstGeom prst="rect">
             <a:avLst/>
@@ -16395,100 +16824,32 @@
           <a:p>
             <a:pPr algn="l"/>
             <a:r>
-              <a:rPr sz="1600" b="1">
-                <a:solidFill>
-                  <a:srgbClr val="1A237E"/>
-                </a:solidFill>
-              </a:rPr>
-              <a:t>Whisper large-v3 でのFTと比較</a:t>
-            </a:r>
-          </a:p>
-        </p:txBody>
-      </p:sp>
-      <p:sp>
-        <p:nvSpPr>
-          <p:cNvPr id="7" name="TextBox 6"/>
-          <p:cNvSpPr txBox="1"/>
-          <p:nvPr/>
-        </p:nvSpPr>
-        <p:spPr>
-          <a:xfrm>
-            <a:off x="640080" y="2267712"/>
-            <a:ext cx="10972800" cy="292608"/>
-          </a:xfrm>
-          <a:prstGeom prst="rect">
-            <a:avLst/>
-          </a:prstGeom>
-          <a:noFill/>
-        </p:spPr>
-        <p:txBody>
-          <a:bodyPr wrap="square">
-            <a:spAutoFit/>
-          </a:bodyPr>
-          <a:lstStyle/>
-          <a:p>
-            <a:pPr algn="l"/>
-            <a:r>
-              <a:rPr sz="1300" b="0">
+              <a:rPr sz="1400" b="0">
                 <a:solidFill>
                   <a:srgbClr val="212121"/>
                 </a:solidFill>
               </a:rPr>
-              <a:t>・ smallとlargeでFT効果の差を比較</a:t>
-            </a:r>
-          </a:p>
-        </p:txBody>
-      </p:sp>
-      <p:sp>
-        <p:nvSpPr>
-          <p:cNvPr id="8" name="TextBox 7"/>
-          <p:cNvSpPr txBox="1"/>
-          <p:nvPr/>
-        </p:nvSpPr>
-        <p:spPr>
-          <a:xfrm>
-            <a:off x="640080" y="2587752"/>
-            <a:ext cx="10972800" cy="292608"/>
-          </a:xfrm>
-          <a:prstGeom prst="rect">
-            <a:avLst/>
-          </a:prstGeom>
-          <a:noFill/>
-        </p:spPr>
-        <p:txBody>
-          <a:bodyPr wrap="square">
-            <a:spAutoFit/>
-          </a:bodyPr>
-          <a:lstStyle/>
-          <a:p>
-            <a:pPr algn="l"/>
-            <a:r>
-              <a:rPr sz="1300" b="0">
-                <a:solidFill>
-                  <a:srgbClr val="212121"/>
-                </a:solidFill>
-              </a:rPr>
-              <a:t>・ モデルサイズとドメイン適応効果の関係を明らかにする</a:t>
-            </a:r>
-          </a:p>
-        </p:txBody>
-      </p:sp>
-      <p:sp>
-        <p:nvSpPr>
-          <p:cNvPr id="9" name="Rectangle 8"/>
+              <a:t>DSP-onlyおよびGTCRNは全ノイズ条件でCERを有意に悪化させる（30検定中26件 p&lt;0.05）</a:t>
+            </a:r>
+          </a:p>
+        </p:txBody>
+      </p:sp>
+      <p:sp>
+        <p:nvSpPr>
+          <p:cNvPr id="8" name="Rectangle 7"/>
           <p:cNvSpPr/>
           <p:nvPr/>
         </p:nvSpPr>
         <p:spPr>
           <a:xfrm>
-            <a:off x="365760" y="3063240"/>
-            <a:ext cx="11430000" cy="1463040"/>
+            <a:off x="365760" y="2212848"/>
+            <a:ext cx="11430000" cy="621792"/>
           </a:xfrm>
           <a:prstGeom prst="rect">
             <a:avLst/>
           </a:prstGeom>
           <a:solidFill>
-            <a:srgbClr val="FFF8E1"/>
+            <a:srgbClr val="F5F5F5"/>
           </a:solidFill>
           <a:ln>
             <a:noFill/>
@@ -16518,14 +16879,48 @@
       </p:sp>
       <p:sp>
         <p:nvSpPr>
+          <p:cNvPr id="9" name="TextBox 8"/>
+          <p:cNvSpPr txBox="1"/>
+          <p:nvPr/>
+        </p:nvSpPr>
+        <p:spPr>
+          <a:xfrm>
+            <a:off x="502920" y="2304288"/>
+            <a:ext cx="731520" cy="411480"/>
+          </a:xfrm>
+          <a:prstGeom prst="rect">
+            <a:avLst/>
+          </a:prstGeom>
+          <a:noFill/>
+        </p:spPr>
+        <p:txBody>
+          <a:bodyPr wrap="square">
+            <a:spAutoFit/>
+          </a:bodyPr>
+          <a:lstStyle/>
+          <a:p>
+            <a:pPr algn="l"/>
+            <a:r>
+              <a:rPr sz="1400" b="1">
+                <a:solidFill>
+                  <a:srgbClr val="FF9800"/>
+                </a:solidFill>
+              </a:rPr>
+              <a:t>（2）</a:t>
+            </a:r>
+          </a:p>
+        </p:txBody>
+      </p:sp>
+      <p:sp>
+        <p:nvSpPr>
           <p:cNvPr id="10" name="TextBox 9"/>
           <p:cNvSpPr txBox="1"/>
           <p:nvPr/>
         </p:nvSpPr>
         <p:spPr>
           <a:xfrm>
-            <a:off x="502920" y="3108960"/>
-            <a:ext cx="2560320" cy="320040"/>
+            <a:off x="1143000" y="2304288"/>
+            <a:ext cx="10424160" cy="411480"/>
           </a:xfrm>
           <a:prstGeom prst="rect">
             <a:avLst/>
@@ -16540,134 +16935,32 @@
           <a:p>
             <a:pPr algn="l"/>
             <a:r>
-              <a:rPr sz="1100" b="1">
-                <a:solidFill>
-                  <a:srgbClr val="78909C"/>
-                </a:solidFill>
-              </a:rPr>
-              <a:t>優先度：中</a:t>
-            </a:r>
-          </a:p>
-        </p:txBody>
-      </p:sp>
-      <p:sp>
-        <p:nvSpPr>
-          <p:cNvPr id="11" name="TextBox 10"/>
-          <p:cNvSpPr txBox="1"/>
-          <p:nvPr/>
-        </p:nvSpPr>
-        <p:spPr>
-          <a:xfrm>
-            <a:off x="502920" y="3410712"/>
-            <a:ext cx="11064240" cy="384048"/>
-          </a:xfrm>
-          <a:prstGeom prst="rect">
-            <a:avLst/>
-          </a:prstGeom>
-          <a:noFill/>
-        </p:spPr>
-        <p:txBody>
-          <a:bodyPr wrap="square">
-            <a:spAutoFit/>
-          </a:bodyPr>
-          <a:lstStyle/>
-          <a:p>
-            <a:pPr algn="l"/>
-            <a:r>
-              <a:rPr sz="1600" b="1">
-                <a:solidFill>
-                  <a:srgbClr val="1A237E"/>
-                </a:solidFill>
-              </a:rPr>
-              <a:t>ノイズ条件下でのWhisper FT評価</a:t>
-            </a:r>
-          </a:p>
-        </p:txBody>
-      </p:sp>
-      <p:sp>
-        <p:nvSpPr>
-          <p:cNvPr id="12" name="TextBox 11"/>
-          <p:cNvSpPr txBox="1"/>
-          <p:nvPr/>
-        </p:nvSpPr>
-        <p:spPr>
-          <a:xfrm>
-            <a:off x="640080" y="3867912"/>
-            <a:ext cx="10972800" cy="292608"/>
-          </a:xfrm>
-          <a:prstGeom prst="rect">
-            <a:avLst/>
-          </a:prstGeom>
-          <a:noFill/>
-        </p:spPr>
-        <p:txBody>
-          <a:bodyPr wrap="square">
-            <a:spAutoFit/>
-          </a:bodyPr>
-          <a:lstStyle/>
-          <a:p>
-            <a:pPr algn="l"/>
-            <a:r>
-              <a:rPr sz="1300" b="0">
+              <a:rPr sz="1400" b="0">
                 <a:solidFill>
                   <a:srgbClr val="212121"/>
                 </a:solidFill>
               </a:rPr>
-              <a:t>・ 現在のFT評価はクリーン音声のみ</a:t>
-            </a:r>
-          </a:p>
-        </p:txBody>
-      </p:sp>
-      <p:sp>
-        <p:nvSpPr>
-          <p:cNvPr id="13" name="TextBox 12"/>
-          <p:cNvSpPr txBox="1"/>
-          <p:nvPr/>
-        </p:nvSpPr>
-        <p:spPr>
-          <a:xfrm>
-            <a:off x="640080" y="4187952"/>
-            <a:ext cx="10972800" cy="292608"/>
-          </a:xfrm>
-          <a:prstGeom prst="rect">
-            <a:avLst/>
-          </a:prstGeom>
-          <a:noFill/>
-        </p:spPr>
-        <p:txBody>
-          <a:bodyPr wrap="square">
-            <a:spAutoFit/>
-          </a:bodyPr>
-          <a:lstStyle/>
-          <a:p>
-            <a:pPr algn="l"/>
-            <a:r>
-              <a:rPr sz="1300" b="0">
-                <a:solidFill>
-                  <a:srgbClr val="212121"/>
-                </a:solidFill>
-              </a:rPr>
-              <a:t>・ フェーズ1と同じSNR条件（白色・ピンクノイズ）でのCER比較</a:t>
-            </a:r>
-          </a:p>
-        </p:txBody>
-      </p:sp>
-      <p:sp>
-        <p:nvSpPr>
-          <p:cNvPr id="14" name="Rectangle 13"/>
+              <a:t>GTCRNはSTOI・PESQを改善しながらCERを悪化させる三重パラドックスが全ノイズ条件で観測された</a:t>
+            </a:r>
+          </a:p>
+        </p:txBody>
+      </p:sp>
+      <p:sp>
+        <p:nvSpPr>
+          <p:cNvPr id="11" name="Rectangle 10"/>
           <p:cNvSpPr/>
           <p:nvPr/>
         </p:nvSpPr>
         <p:spPr>
           <a:xfrm>
-            <a:off x="365760" y="4663440"/>
-            <a:ext cx="11430000" cy="1463040"/>
+            <a:off x="365760" y="2916936"/>
+            <a:ext cx="11430000" cy="621792"/>
           </a:xfrm>
           <a:prstGeom prst="rect">
             <a:avLst/>
           </a:prstGeom>
           <a:solidFill>
-            <a:srgbClr val="E8F5E9"/>
+            <a:srgbClr val="F5F5F5"/>
           </a:solidFill>
           <a:ln>
             <a:noFill/>
@@ -16697,14 +16990,125 @@
       </p:sp>
       <p:sp>
         <p:nvSpPr>
+          <p:cNvPr id="12" name="TextBox 11"/>
+          <p:cNvSpPr txBox="1"/>
+          <p:nvPr/>
+        </p:nvSpPr>
+        <p:spPr>
+          <a:xfrm>
+            <a:off x="502920" y="3008376"/>
+            <a:ext cx="731520" cy="411480"/>
+          </a:xfrm>
+          <a:prstGeom prst="rect">
+            <a:avLst/>
+          </a:prstGeom>
+          <a:noFill/>
+        </p:spPr>
+        <p:txBody>
+          <a:bodyPr wrap="square">
+            <a:spAutoFit/>
+          </a:bodyPr>
+          <a:lstStyle/>
+          <a:p>
+            <a:pPr algn="l"/>
+            <a:r>
+              <a:rPr sz="1400" b="1">
+                <a:solidFill>
+                  <a:srgbClr val="FF9800"/>
+                </a:solidFill>
+              </a:rPr>
+              <a:t>（3）</a:t>
+            </a:r>
+          </a:p>
+        </p:txBody>
+      </p:sp>
+      <p:sp>
+        <p:nvSpPr>
+          <p:cNvPr id="13" name="TextBox 12"/>
+          <p:cNvSpPr txBox="1"/>
+          <p:nvPr/>
+        </p:nvSpPr>
+        <p:spPr>
+          <a:xfrm>
+            <a:off x="1143000" y="3008376"/>
+            <a:ext cx="10424160" cy="411480"/>
+          </a:xfrm>
+          <a:prstGeom prst="rect">
+            <a:avLst/>
+          </a:prstGeom>
+          <a:noFill/>
+        </p:spPr>
+        <p:txBody>
+          <a:bodyPr wrap="square">
+            <a:spAutoFit/>
+          </a:bodyPr>
+          <a:lstStyle/>
+          <a:p>
+            <a:pPr algn="l"/>
+            <a:r>
+              <a:rPr sz="1400" b="0">
+                <a:solidFill>
+                  <a:srgbClr val="212121"/>
+                </a:solidFill>
+              </a:rPr>
+              <a:t>DSP-onlyは3指標すべてを悪化させ、喉マイクには不適切な前処理である</a:t>
+            </a:r>
+          </a:p>
+        </p:txBody>
+      </p:sp>
+      <p:sp>
+        <p:nvSpPr>
+          <p:cNvPr id="14" name="Rectangle 13"/>
+          <p:cNvSpPr/>
+          <p:nvPr/>
+        </p:nvSpPr>
+        <p:spPr>
+          <a:xfrm>
+            <a:off x="365760" y="3621024"/>
+            <a:ext cx="11430000" cy="621792"/>
+          </a:xfrm>
+          <a:prstGeom prst="rect">
+            <a:avLst/>
+          </a:prstGeom>
+          <a:solidFill>
+            <a:srgbClr val="F5F5F5"/>
+          </a:solidFill>
+          <a:ln>
+            <a:noFill/>
+          </a:ln>
+        </p:spPr>
+        <p:style>
+          <a:lnRef idx="1">
+            <a:schemeClr val="accent1"/>
+          </a:lnRef>
+          <a:fillRef idx="3">
+            <a:schemeClr val="accent1"/>
+          </a:fillRef>
+          <a:effectRef idx="2">
+            <a:schemeClr val="accent1"/>
+          </a:effectRef>
+          <a:fontRef idx="minor">
+            <a:schemeClr val="lt1"/>
+          </a:fontRef>
+        </p:style>
+        <p:txBody>
+          <a:bodyPr rtlCol="0" anchor="ctr"/>
+          <a:lstStyle/>
+          <a:p>
+            <a:pPr algn="ctr"/>
+          </a:p>
+        </p:txBody>
+      </p:sp>
+      <p:sp>
+        <p:nvSpPr>
           <p:cNvPr id="15" name="TextBox 14"/>
           <p:cNvSpPr txBox="1"/>
           <p:nvPr/>
         </p:nvSpPr>
         <p:spPr>
           <a:xfrm>
-            <a:off x="502920" y="4709160"/>
-            <a:ext cx="2560320" cy="320040"/>
+            <a:off x="502920" y="3712464"/>
+            <a:ext cx="731520" cy="411480"/>
           </a:xfrm>
           <a:prstGeom prst="rect">
             <a:avLst/>
@@ -16719,12 +17123,12 @@
           <a:p>
             <a:pPr algn="l"/>
             <a:r>
-              <a:rPr sz="1100" b="1">
-                <a:solidFill>
-                  <a:srgbClr val="78909C"/>
-                </a:solidFill>
-              </a:rPr>
-              <a:t>優先度：中</a:t>
+              <a:rPr sz="1400" b="1">
+                <a:solidFill>
+                  <a:srgbClr val="43A047"/>
+                </a:solidFill>
+              </a:rPr>
+              <a:t>（4）</a:t>
             </a:r>
           </a:p>
         </p:txBody>
@@ -16737,8 +17141,8 @@
         </p:nvSpPr>
         <p:spPr>
           <a:xfrm>
-            <a:off x="502920" y="5010912"/>
-            <a:ext cx="11064240" cy="384048"/>
+            <a:off x="1143000" y="3712464"/>
+            <a:ext cx="10424160" cy="411480"/>
           </a:xfrm>
           <a:prstGeom prst="rect">
             <a:avLst/>
@@ -16753,26 +17157,69 @@
           <a:p>
             <a:pPr algn="l"/>
             <a:r>
-              <a:rPr sz="1600" b="1">
-                <a:solidFill>
-                  <a:srgbClr val="1A237E"/>
-                </a:solidFill>
-              </a:rPr>
-              <a:t>実環境ノイズでの検証</a:t>
-            </a:r>
-          </a:p>
-        </p:txBody>
-      </p:sp>
-      <p:sp>
-        <p:nvSpPr>
-          <p:cNvPr id="17" name="TextBox 16"/>
-          <p:cNvSpPr txBox="1"/>
-          <p:nvPr/>
-        </p:nvSpPr>
-        <p:spPr>
-          <a:xfrm>
-            <a:off x="640080" y="5468112"/>
-            <a:ext cx="10972800" cy="292608"/>
+              <a:rPr sz="1400" b="0">
+                <a:solidFill>
+                  <a:srgbClr val="212121"/>
+                </a:solidFill>
+              </a:rPr>
+              <a:t>Whisper smallのFTによりCERが0.269→0.095（64.6%改善）—「ASR側の適応」が音声処理より有効</a:t>
+            </a:r>
+          </a:p>
+        </p:txBody>
+      </p:sp>
+      <p:sp>
+        <p:nvSpPr>
+          <p:cNvPr id="17" name="Rectangle 16"/>
+          <p:cNvSpPr/>
+          <p:nvPr/>
+        </p:nvSpPr>
+        <p:spPr>
+          <a:xfrm>
+            <a:off x="365760" y="4325112"/>
+            <a:ext cx="11430000" cy="621792"/>
+          </a:xfrm>
+          <a:prstGeom prst="rect">
+            <a:avLst/>
+          </a:prstGeom>
+          <a:solidFill>
+            <a:srgbClr val="F5F5F5"/>
+          </a:solidFill>
+          <a:ln>
+            <a:noFill/>
+          </a:ln>
+        </p:spPr>
+        <p:style>
+          <a:lnRef idx="1">
+            <a:schemeClr val="accent1"/>
+          </a:lnRef>
+          <a:fillRef idx="3">
+            <a:schemeClr val="accent1"/>
+          </a:fillRef>
+          <a:effectRef idx="2">
+            <a:schemeClr val="accent1"/>
+          </a:effectRef>
+          <a:fontRef idx="minor">
+            <a:schemeClr val="lt1"/>
+          </a:fontRef>
+        </p:style>
+        <p:txBody>
+          <a:bodyPr rtlCol="0" anchor="ctr"/>
+          <a:lstStyle/>
+          <a:p>
+            <a:pPr algn="ctr"/>
+          </a:p>
+        </p:txBody>
+      </p:sp>
+      <p:sp>
+        <p:nvSpPr>
+          <p:cNvPr id="18" name="TextBox 17"/>
+          <p:cNvSpPr txBox="1"/>
+          <p:nvPr/>
+        </p:nvSpPr>
+        <p:spPr>
+          <a:xfrm>
+            <a:off x="502920" y="4416552"/>
+            <a:ext cx="731520" cy="411480"/>
           </a:xfrm>
           <a:prstGeom prst="rect">
             <a:avLst/>
@@ -16787,53 +17234,53 @@
           <a:p>
             <a:pPr algn="l"/>
             <a:r>
-              <a:rPr sz="1300" b="0">
+              <a:rPr sz="1400" b="1">
+                <a:solidFill>
+                  <a:srgbClr val="43A047"/>
+                </a:solidFill>
+              </a:rPr>
+              <a:t>（5）</a:t>
+            </a:r>
+          </a:p>
+        </p:txBody>
+      </p:sp>
+      <p:sp>
+        <p:nvSpPr>
+          <p:cNvPr id="19" name="TextBox 18"/>
+          <p:cNvSpPr txBox="1"/>
+          <p:nvPr/>
+        </p:nvSpPr>
+        <p:spPr>
+          <a:xfrm>
+            <a:off x="1143000" y="4416552"/>
+            <a:ext cx="10424160" cy="411480"/>
+          </a:xfrm>
+          <a:prstGeom prst="rect">
+            <a:avLst/>
+          </a:prstGeom>
+          <a:noFill/>
+        </p:spPr>
+        <p:txBody>
+          <a:bodyPr wrap="square">
+            <a:spAutoFit/>
+          </a:bodyPr>
+          <a:lstStyle/>
+          <a:p>
+            <a:pPr algn="l"/>
+            <a:r>
+              <a:rPr sz="1400" b="0">
                 <a:solidFill>
                   <a:srgbClr val="212121"/>
                 </a:solidFill>
               </a:rPr>
-              <a:t>・ 現在は人工ノイズ（白色・ピンク）のみ</a:t>
-            </a:r>
-          </a:p>
-        </p:txBody>
-      </p:sp>
-      <p:sp>
-        <p:nvSpPr>
-          <p:cNvPr id="18" name="TextBox 17"/>
-          <p:cNvSpPr txBox="1"/>
-          <p:nvPr/>
-        </p:nvSpPr>
-        <p:spPr>
-          <a:xfrm>
-            <a:off x="640080" y="5788152"/>
-            <a:ext cx="10972800" cy="292608"/>
-          </a:xfrm>
-          <a:prstGeom prst="rect">
-            <a:avLst/>
-          </a:prstGeom>
-          <a:noFill/>
-        </p:spPr>
-        <p:txBody>
-          <a:bodyPr wrap="square">
-            <a:spAutoFit/>
-          </a:bodyPr>
-          <a:lstStyle/>
-          <a:p>
-            <a:pPr algn="l"/>
-            <a:r>
-              <a:rPr sz="1300" b="0">
-                <a:solidFill>
-                  <a:srgbClr val="212121"/>
-                </a:solidFill>
-              </a:rPr>
-              <a:t>・ MUSAN・DEMANDなどの実録音ノイズで再現実験</a:t>
-            </a:r>
-          </a:p>
-        </p:txBody>
-      </p:sp>
-      <p:sp>
-        <p:nvSpPr>
-          <p:cNvPr id="19" name="Rectangle 18"/>
+              <a:t>FT後もSEの逆効果は残存するが悪化幅は縮小（+0.027→+0.007）—FTがSEアーティファクトへの感受性を低減</a:t>
+            </a:r>
+          </a:p>
+        </p:txBody>
+      </p:sp>
+      <p:sp>
+        <p:nvSpPr>
+          <p:cNvPr id="20" name="Rectangle 19"/>
           <p:cNvSpPr/>
           <p:nvPr/>
         </p:nvSpPr>
@@ -16876,7 +17323,7 @@
       </p:sp>
       <p:sp>
         <p:nvSpPr>
-          <p:cNvPr id="20" name="TextBox 19"/>
+          <p:cNvPr id="21" name="TextBox 20"/>
           <p:cNvSpPr txBox="1"/>
           <p:nvPr/>
         </p:nvSpPr>
@@ -16903,7 +17350,7 @@
                   <a:srgbClr val="1A237E"/>
                 </a:solidFill>
               </a:rPr>
-              <a:t>25 / 25</a:t>
+              <a:t>25 / 28</a:t>
             </a:r>
           </a:p>
         </p:txBody>
@@ -16998,7 +17445,7 @@
                   <a:srgbClr val="FFFFFF"/>
                 </a:solidFill>
               </a:rPr>
-              <a:t>参考文献</a:t>
+              <a:t>今後の展望</a:t>
             </a:r>
           </a:p>
         </p:txBody>
@@ -17011,14 +17458,14 @@
         </p:nvSpPr>
         <p:spPr>
           <a:xfrm>
-            <a:off x="365760" y="1508760"/>
-            <a:ext cx="11430000" cy="1143000"/>
+            <a:off x="365760" y="1463040"/>
+            <a:ext cx="11430000" cy="1463040"/>
           </a:xfrm>
           <a:prstGeom prst="rect">
             <a:avLst/>
           </a:prstGeom>
           <a:solidFill>
-            <a:srgbClr val="F5F5F5"/>
+            <a:srgbClr val="FFEBEE"/>
           </a:solidFill>
           <a:ln>
             <a:noFill/>
@@ -17054,8 +17501,8 @@
         </p:nvSpPr>
         <p:spPr>
           <a:xfrm>
-            <a:off x="502920" y="1581912"/>
-            <a:ext cx="11155680" cy="1005840"/>
+            <a:off x="502920" y="1508760"/>
+            <a:ext cx="2560320" cy="320040"/>
           </a:xfrm>
           <a:prstGeom prst="rect">
             <a:avLst/>
@@ -17070,35 +17517,134 @@
           <a:p>
             <a:pPr algn="l"/>
             <a:r>
-              <a:rPr sz="1200" b="0">
+              <a:rPr sz="1100" b="1">
+                <a:solidFill>
+                  <a:srgbClr val="78909C"/>
+                </a:solidFill>
+              </a:rPr>
+              <a:t>優先度：高</a:t>
+            </a:r>
+          </a:p>
+        </p:txBody>
+      </p:sp>
+      <p:sp>
+        <p:nvSpPr>
+          <p:cNvPr id="6" name="TextBox 5"/>
+          <p:cNvSpPr txBox="1"/>
+          <p:nvPr/>
+        </p:nvSpPr>
+        <p:spPr>
+          <a:xfrm>
+            <a:off x="502920" y="1810512"/>
+            <a:ext cx="11064240" cy="384048"/>
+          </a:xfrm>
+          <a:prstGeom prst="rect">
+            <a:avLst/>
+          </a:prstGeom>
+          <a:noFill/>
+        </p:spPr>
+        <p:txBody>
+          <a:bodyPr wrap="square">
+            <a:spAutoFit/>
+          </a:bodyPr>
+          <a:lstStyle/>
+          <a:p>
+            <a:pPr algn="l"/>
+            <a:r>
+              <a:rPr sz="1600" b="1">
+                <a:solidFill>
+                  <a:srgbClr val="1A237E"/>
+                </a:solidFill>
+              </a:rPr>
+              <a:t>Whisper large-v3 でのFTと比較</a:t>
+            </a:r>
+          </a:p>
+        </p:txBody>
+      </p:sp>
+      <p:sp>
+        <p:nvSpPr>
+          <p:cNvPr id="7" name="TextBox 6"/>
+          <p:cNvSpPr txBox="1"/>
+          <p:nvPr/>
+        </p:nvSpPr>
+        <p:spPr>
+          <a:xfrm>
+            <a:off x="640080" y="2267712"/>
+            <a:ext cx="10972800" cy="292608"/>
+          </a:xfrm>
+          <a:prstGeom prst="rect">
+            <a:avLst/>
+          </a:prstGeom>
+          <a:noFill/>
+        </p:spPr>
+        <p:txBody>
+          <a:bodyPr wrap="square">
+            <a:spAutoFit/>
+          </a:bodyPr>
+          <a:lstStyle/>
+          <a:p>
+            <a:pPr algn="l"/>
+            <a:r>
+              <a:rPr sz="1300" b="0">
                 <a:solidFill>
                   <a:srgbClr val="212121"/>
                 </a:solidFill>
               </a:rPr>
-              <a:t>[1]  C.O. Mawalim, S. Okada, M. Unoki,
-     "Are Recent Deep Learning-Based Speech Enhancement Methods Ready to Confront
-     Real-World Noisy Environments?"
-     Interspeech 2024, pp. 1735–1739, DOI: 10.21437/Interspeech.2024-129</a:t>
-            </a:r>
-          </a:p>
-        </p:txBody>
-      </p:sp>
-      <p:sp>
-        <p:nvSpPr>
-          <p:cNvPr id="6" name="Rectangle 5"/>
+              <a:t>・ smallとlargeでFT効果の差を比較</a:t>
+            </a:r>
+          </a:p>
+        </p:txBody>
+      </p:sp>
+      <p:sp>
+        <p:nvSpPr>
+          <p:cNvPr id="8" name="TextBox 7"/>
+          <p:cNvSpPr txBox="1"/>
+          <p:nvPr/>
+        </p:nvSpPr>
+        <p:spPr>
+          <a:xfrm>
+            <a:off x="640080" y="2587752"/>
+            <a:ext cx="10972800" cy="292608"/>
+          </a:xfrm>
+          <a:prstGeom prst="rect">
+            <a:avLst/>
+          </a:prstGeom>
+          <a:noFill/>
+        </p:spPr>
+        <p:txBody>
+          <a:bodyPr wrap="square">
+            <a:spAutoFit/>
+          </a:bodyPr>
+          <a:lstStyle/>
+          <a:p>
+            <a:pPr algn="l"/>
+            <a:r>
+              <a:rPr sz="1300" b="0">
+                <a:solidFill>
+                  <a:srgbClr val="212121"/>
+                </a:solidFill>
+              </a:rPr>
+              <a:t>・ モデルサイズとドメイン適応効果の関係を明らかにする</a:t>
+            </a:r>
+          </a:p>
+        </p:txBody>
+      </p:sp>
+      <p:sp>
+        <p:nvSpPr>
+          <p:cNvPr id="9" name="Rectangle 8"/>
           <p:cNvSpPr/>
           <p:nvPr/>
         </p:nvSpPr>
         <p:spPr>
           <a:xfrm>
-            <a:off x="365760" y="2743200"/>
-            <a:ext cx="11430000" cy="1143000"/>
+            <a:off x="365760" y="3063240"/>
+            <a:ext cx="11430000" cy="1463040"/>
           </a:xfrm>
           <a:prstGeom prst="rect">
             <a:avLst/>
           </a:prstGeom>
           <a:solidFill>
-            <a:srgbClr val="F5F5F5"/>
+            <a:srgbClr val="FFF8E1"/>
           </a:solidFill>
           <a:ln>
             <a:noFill/>
@@ -17128,14 +17674,14 @@
       </p:sp>
       <p:sp>
         <p:nvSpPr>
-          <p:cNvPr id="7" name="TextBox 6"/>
-          <p:cNvSpPr txBox="1"/>
-          <p:nvPr/>
-        </p:nvSpPr>
-        <p:spPr>
-          <a:xfrm>
-            <a:off x="502920" y="2816352"/>
-            <a:ext cx="11155680" cy="1005840"/>
+          <p:cNvPr id="10" name="TextBox 9"/>
+          <p:cNvSpPr txBox="1"/>
+          <p:nvPr/>
+        </p:nvSpPr>
+        <p:spPr>
+          <a:xfrm>
+            <a:off x="502920" y="3108960"/>
+            <a:ext cx="2560320" cy="320040"/>
           </a:xfrm>
           <a:prstGeom prst="rect">
             <a:avLst/>
@@ -17150,35 +17696,134 @@
           <a:p>
             <a:pPr algn="l"/>
             <a:r>
-              <a:rPr sz="1200" b="0">
+              <a:rPr sz="1100" b="1">
+                <a:solidFill>
+                  <a:srgbClr val="78909C"/>
+                </a:solidFill>
+              </a:rPr>
+              <a:t>優先度：中</a:t>
+            </a:r>
+          </a:p>
+        </p:txBody>
+      </p:sp>
+      <p:sp>
+        <p:nvSpPr>
+          <p:cNvPr id="11" name="TextBox 10"/>
+          <p:cNvSpPr txBox="1"/>
+          <p:nvPr/>
+        </p:nvSpPr>
+        <p:spPr>
+          <a:xfrm>
+            <a:off x="502920" y="3410712"/>
+            <a:ext cx="11064240" cy="384048"/>
+          </a:xfrm>
+          <a:prstGeom prst="rect">
+            <a:avLst/>
+          </a:prstGeom>
+          <a:noFill/>
+        </p:spPr>
+        <p:txBody>
+          <a:bodyPr wrap="square">
+            <a:spAutoFit/>
+          </a:bodyPr>
+          <a:lstStyle/>
+          <a:p>
+            <a:pPr algn="l"/>
+            <a:r>
+              <a:rPr sz="1600" b="1">
+                <a:solidFill>
+                  <a:srgbClr val="1A237E"/>
+                </a:solidFill>
+              </a:rPr>
+              <a:t>ノイズ条件下でのWhisper FT評価</a:t>
+            </a:r>
+          </a:p>
+        </p:txBody>
+      </p:sp>
+      <p:sp>
+        <p:nvSpPr>
+          <p:cNvPr id="12" name="TextBox 11"/>
+          <p:cNvSpPr txBox="1"/>
+          <p:nvPr/>
+        </p:nvSpPr>
+        <p:spPr>
+          <a:xfrm>
+            <a:off x="640080" y="3867912"/>
+            <a:ext cx="10972800" cy="292608"/>
+          </a:xfrm>
+          <a:prstGeom prst="rect">
+            <a:avLst/>
+          </a:prstGeom>
+          <a:noFill/>
+        </p:spPr>
+        <p:txBody>
+          <a:bodyPr wrap="square">
+            <a:spAutoFit/>
+          </a:bodyPr>
+          <a:lstStyle/>
+          <a:p>
+            <a:pPr algn="l"/>
+            <a:r>
+              <a:rPr sz="1300" b="0">
                 <a:solidFill>
                   <a:srgbClr val="212121"/>
                 </a:solidFill>
               </a:rPr>
-              <a:t>[2]  T. Ochiai, K. Iwamoto, M. Delcroix et al.,
-     "Rethinking Processing Distortions: How Do They Affect the Downstream ASR Performance?"
-     IEEE/ACM Transactions on Audio, Speech, and Language Processing, TASLP 2024,
-     arXiv:2404.14860</a:t>
-            </a:r>
-          </a:p>
-        </p:txBody>
-      </p:sp>
-      <p:sp>
-        <p:nvSpPr>
-          <p:cNvPr id="8" name="Rectangle 7"/>
+              <a:t>・ 現在のFT評価はクリーン音声のみ</a:t>
+            </a:r>
+          </a:p>
+        </p:txBody>
+      </p:sp>
+      <p:sp>
+        <p:nvSpPr>
+          <p:cNvPr id="13" name="TextBox 12"/>
+          <p:cNvSpPr txBox="1"/>
+          <p:nvPr/>
+        </p:nvSpPr>
+        <p:spPr>
+          <a:xfrm>
+            <a:off x="640080" y="4187952"/>
+            <a:ext cx="10972800" cy="292608"/>
+          </a:xfrm>
+          <a:prstGeom prst="rect">
+            <a:avLst/>
+          </a:prstGeom>
+          <a:noFill/>
+        </p:spPr>
+        <p:txBody>
+          <a:bodyPr wrap="square">
+            <a:spAutoFit/>
+          </a:bodyPr>
+          <a:lstStyle/>
+          <a:p>
+            <a:pPr algn="l"/>
+            <a:r>
+              <a:rPr sz="1300" b="0">
+                <a:solidFill>
+                  <a:srgbClr val="212121"/>
+                </a:solidFill>
+              </a:rPr>
+              <a:t>・ フェーズ1と同じSNR条件（白色・ピンクノイズ）でのCER比較</a:t>
+            </a:r>
+          </a:p>
+        </p:txBody>
+      </p:sp>
+      <p:sp>
+        <p:nvSpPr>
+          <p:cNvPr id="14" name="Rectangle 13"/>
           <p:cNvSpPr/>
           <p:nvPr/>
         </p:nvSpPr>
         <p:spPr>
           <a:xfrm>
-            <a:off x="365760" y="3977640"/>
-            <a:ext cx="11430000" cy="1143000"/>
+            <a:off x="365760" y="4663440"/>
+            <a:ext cx="11430000" cy="1463040"/>
           </a:xfrm>
           <a:prstGeom prst="rect">
             <a:avLst/>
           </a:prstGeom>
           <a:solidFill>
-            <a:srgbClr val="F5F5F5"/>
+            <a:srgbClr val="E8F5E9"/>
           </a:solidFill>
           <a:ln>
             <a:noFill/>
@@ -17208,14 +17853,14 @@
       </p:sp>
       <p:sp>
         <p:nvSpPr>
-          <p:cNvPr id="9" name="TextBox 8"/>
-          <p:cNvSpPr txBox="1"/>
-          <p:nvPr/>
-        </p:nvSpPr>
-        <p:spPr>
-          <a:xfrm>
-            <a:off x="502920" y="4050792"/>
-            <a:ext cx="11155680" cy="1005840"/>
+          <p:cNvPr id="15" name="TextBox 14"/>
+          <p:cNvSpPr txBox="1"/>
+          <p:nvPr/>
+        </p:nvSpPr>
+        <p:spPr>
+          <a:xfrm>
+            <a:off x="502920" y="4709160"/>
+            <a:ext cx="2560320" cy="320040"/>
           </a:xfrm>
           <a:prstGeom prst="rect">
             <a:avLst/>
@@ -17230,71 +17875,94 @@
           <a:p>
             <a:pPr algn="l"/>
             <a:r>
-              <a:rPr sz="1200" b="0">
+              <a:rPr sz="1100" b="1">
+                <a:solidFill>
+                  <a:srgbClr val="78909C"/>
+                </a:solidFill>
+              </a:rPr>
+              <a:t>優先度：中</a:t>
+            </a:r>
+          </a:p>
+        </p:txBody>
+      </p:sp>
+      <p:sp>
+        <p:nvSpPr>
+          <p:cNvPr id="16" name="TextBox 15"/>
+          <p:cNvSpPr txBox="1"/>
+          <p:nvPr/>
+        </p:nvSpPr>
+        <p:spPr>
+          <a:xfrm>
+            <a:off x="502920" y="5010912"/>
+            <a:ext cx="11064240" cy="384048"/>
+          </a:xfrm>
+          <a:prstGeom prst="rect">
+            <a:avLst/>
+          </a:prstGeom>
+          <a:noFill/>
+        </p:spPr>
+        <p:txBody>
+          <a:bodyPr wrap="square">
+            <a:spAutoFit/>
+          </a:bodyPr>
+          <a:lstStyle/>
+          <a:p>
+            <a:pPr algn="l"/>
+            <a:r>
+              <a:rPr sz="1600" b="1">
+                <a:solidFill>
+                  <a:srgbClr val="1A237E"/>
+                </a:solidFill>
+              </a:rPr>
+              <a:t>実環境ノイズでの検証</a:t>
+            </a:r>
+          </a:p>
+        </p:txBody>
+      </p:sp>
+      <p:sp>
+        <p:nvSpPr>
+          <p:cNvPr id="17" name="TextBox 16"/>
+          <p:cNvSpPr txBox="1"/>
+          <p:nvPr/>
+        </p:nvSpPr>
+        <p:spPr>
+          <a:xfrm>
+            <a:off x="640080" y="5468112"/>
+            <a:ext cx="10972800" cy="292608"/>
+          </a:xfrm>
+          <a:prstGeom prst="rect">
+            <a:avLst/>
+          </a:prstGeom>
+          <a:noFill/>
+        </p:spPr>
+        <p:txBody>
+          <a:bodyPr wrap="square">
+            <a:spAutoFit/>
+          </a:bodyPr>
+          <a:lstStyle/>
+          <a:p>
+            <a:pPr algn="l"/>
+            <a:r>
+              <a:rPr sz="1300" b="0">
                 <a:solidFill>
                   <a:srgbClr val="212121"/>
                 </a:solidFill>
               </a:rPr>
-              <a:t>[3]  X. Rong, C. Li, J. Xiao,
-     "GTCRN: A Speech Enhancement Model Requiring Ultra-Tiny Resources"
-     arXiv:2404.11567, 2024</a:t>
-            </a:r>
-          </a:p>
-        </p:txBody>
-      </p:sp>
-      <p:sp>
-        <p:nvSpPr>
-          <p:cNvPr id="10" name="Rectangle 9"/>
-          <p:cNvSpPr/>
-          <p:nvPr/>
-        </p:nvSpPr>
-        <p:spPr>
-          <a:xfrm>
-            <a:off x="365760" y="5212080"/>
-            <a:ext cx="11430000" cy="1143000"/>
-          </a:xfrm>
-          <a:prstGeom prst="rect">
-            <a:avLst/>
-          </a:prstGeom>
-          <a:solidFill>
-            <a:srgbClr val="F5F5F5"/>
-          </a:solidFill>
-          <a:ln>
-            <a:noFill/>
-          </a:ln>
-        </p:spPr>
-        <p:style>
-          <a:lnRef idx="1">
-            <a:schemeClr val="accent1"/>
-          </a:lnRef>
-          <a:fillRef idx="3">
-            <a:schemeClr val="accent1"/>
-          </a:fillRef>
-          <a:effectRef idx="2">
-            <a:schemeClr val="accent1"/>
-          </a:effectRef>
-          <a:fontRef idx="minor">
-            <a:schemeClr val="lt1"/>
-          </a:fontRef>
-        </p:style>
-        <p:txBody>
-          <a:bodyPr rtlCol="0" anchor="ctr"/>
-          <a:lstStyle/>
-          <a:p>
-            <a:pPr algn="ctr"/>
-          </a:p>
-        </p:txBody>
-      </p:sp>
-      <p:sp>
-        <p:nvSpPr>
-          <p:cNvPr id="11" name="TextBox 10"/>
-          <p:cNvSpPr txBox="1"/>
-          <p:nvPr/>
-        </p:nvSpPr>
-        <p:spPr>
-          <a:xfrm>
-            <a:off x="502920" y="5285232"/>
-            <a:ext cx="11155680" cy="1005840"/>
+              <a:t>・ 現在は人工ノイズ（白色・ピンク）のみ</a:t>
+            </a:r>
+          </a:p>
+        </p:txBody>
+      </p:sp>
+      <p:sp>
+        <p:nvSpPr>
+          <p:cNvPr id="18" name="TextBox 17"/>
+          <p:cNvSpPr txBox="1"/>
+          <p:nvPr/>
+        </p:nvSpPr>
+        <p:spPr>
+          <a:xfrm>
+            <a:off x="640080" y="5788152"/>
+            <a:ext cx="10972800" cy="292608"/>
           </a:xfrm>
           <a:prstGeom prst="rect">
             <a:avLst/>
@@ -17309,21 +17977,19 @@
           <a:p>
             <a:pPr algn="l"/>
             <a:r>
-              <a:rPr sz="1200" b="0">
+              <a:rPr sz="1300" b="0">
                 <a:solidFill>
                   <a:srgbClr val="212121"/>
                 </a:solidFill>
               </a:rPr>
-              <a:t>[4]  Y. Kim et al.,
-     "TAPS: Throat and Acoustic Pairing Speech Dataset"
-     HuggingFace: yskim3271/Throat_and_Acoustic_Pairing_Speech_Dataset</a:t>
-            </a:r>
-          </a:p>
-        </p:txBody>
-      </p:sp>
-      <p:sp>
-        <p:nvSpPr>
-          <p:cNvPr id="12" name="Rectangle 11"/>
+              <a:t>・ MUSAN・DEMANDなどの実録音ノイズで再現実験</a:t>
+            </a:r>
+          </a:p>
+        </p:txBody>
+      </p:sp>
+      <p:sp>
+        <p:nvSpPr>
+          <p:cNvPr id="19" name="Rectangle 18"/>
           <p:cNvSpPr/>
           <p:nvPr/>
         </p:nvSpPr>
@@ -17366,7 +18032,7 @@
       </p:sp>
       <p:sp>
         <p:nvSpPr>
-          <p:cNvPr id="13" name="TextBox 12"/>
+          <p:cNvPr id="20" name="TextBox 19"/>
           <p:cNvSpPr txBox="1"/>
           <p:nvPr/>
         </p:nvSpPr>
@@ -17393,7 +18059,7 @@
                   <a:srgbClr val="1A237E"/>
                 </a:solidFill>
               </a:rPr>
-              <a:t>26 / 25</a:t>
+              <a:t>26 / 28</a:t>
             </a:r>
           </a:p>
         </p:txBody>
@@ -17425,7 +18091,7 @@
         <p:spPr>
           <a:xfrm>
             <a:off x="0" y="0"/>
-            <a:ext cx="12188952" cy="6858000"/>
+            <a:ext cx="12188952" cy="1280160"/>
           </a:xfrm>
           <a:prstGeom prst="rect">
             <a:avLst/>
@@ -17461,6 +18127,496 @@
       </p:sp>
       <p:sp>
         <p:nvSpPr>
+          <p:cNvPr id="3" name="TextBox 2"/>
+          <p:cNvSpPr txBox="1"/>
+          <p:nvPr/>
+        </p:nvSpPr>
+        <p:spPr>
+          <a:xfrm>
+            <a:off x="365760" y="164592"/>
+            <a:ext cx="11430000" cy="822960"/>
+          </a:xfrm>
+          <a:prstGeom prst="rect">
+            <a:avLst/>
+          </a:prstGeom>
+          <a:noFill/>
+        </p:spPr>
+        <p:txBody>
+          <a:bodyPr wrap="square">
+            <a:spAutoFit/>
+          </a:bodyPr>
+          <a:lstStyle/>
+          <a:p>
+            <a:pPr algn="l"/>
+            <a:r>
+              <a:rPr sz="2800" b="1">
+                <a:solidFill>
+                  <a:srgbClr val="FFFFFF"/>
+                </a:solidFill>
+              </a:rPr>
+              <a:t>参考文献</a:t>
+            </a:r>
+          </a:p>
+        </p:txBody>
+      </p:sp>
+      <p:sp>
+        <p:nvSpPr>
+          <p:cNvPr id="4" name="Rectangle 3"/>
+          <p:cNvSpPr/>
+          <p:nvPr/>
+        </p:nvSpPr>
+        <p:spPr>
+          <a:xfrm>
+            <a:off x="365760" y="1508760"/>
+            <a:ext cx="11430000" cy="1143000"/>
+          </a:xfrm>
+          <a:prstGeom prst="rect">
+            <a:avLst/>
+          </a:prstGeom>
+          <a:solidFill>
+            <a:srgbClr val="F5F5F5"/>
+          </a:solidFill>
+          <a:ln>
+            <a:noFill/>
+          </a:ln>
+        </p:spPr>
+        <p:style>
+          <a:lnRef idx="1">
+            <a:schemeClr val="accent1"/>
+          </a:lnRef>
+          <a:fillRef idx="3">
+            <a:schemeClr val="accent1"/>
+          </a:fillRef>
+          <a:effectRef idx="2">
+            <a:schemeClr val="accent1"/>
+          </a:effectRef>
+          <a:fontRef idx="minor">
+            <a:schemeClr val="lt1"/>
+          </a:fontRef>
+        </p:style>
+        <p:txBody>
+          <a:bodyPr rtlCol="0" anchor="ctr"/>
+          <a:lstStyle/>
+          <a:p>
+            <a:pPr algn="ctr"/>
+          </a:p>
+        </p:txBody>
+      </p:sp>
+      <p:sp>
+        <p:nvSpPr>
+          <p:cNvPr id="5" name="TextBox 4"/>
+          <p:cNvSpPr txBox="1"/>
+          <p:nvPr/>
+        </p:nvSpPr>
+        <p:spPr>
+          <a:xfrm>
+            <a:off x="502920" y="1581912"/>
+            <a:ext cx="11155680" cy="1005840"/>
+          </a:xfrm>
+          <a:prstGeom prst="rect">
+            <a:avLst/>
+          </a:prstGeom>
+          <a:noFill/>
+        </p:spPr>
+        <p:txBody>
+          <a:bodyPr wrap="square">
+            <a:spAutoFit/>
+          </a:bodyPr>
+          <a:lstStyle/>
+          <a:p>
+            <a:pPr algn="l"/>
+            <a:r>
+              <a:rPr sz="1200" b="0">
+                <a:solidFill>
+                  <a:srgbClr val="212121"/>
+                </a:solidFill>
+              </a:rPr>
+              <a:t>[1]  C.O. Mawalim, S. Okada, M. Unoki,
+     "Are Recent Deep Learning-Based Speech Enhancement Methods Ready to Confront
+     Real-World Noisy Environments?"
+     Interspeech 2024, pp. 1735–1739, DOI: 10.21437/Interspeech.2024-129</a:t>
+            </a:r>
+          </a:p>
+        </p:txBody>
+      </p:sp>
+      <p:sp>
+        <p:nvSpPr>
+          <p:cNvPr id="6" name="Rectangle 5"/>
+          <p:cNvSpPr/>
+          <p:nvPr/>
+        </p:nvSpPr>
+        <p:spPr>
+          <a:xfrm>
+            <a:off x="365760" y="2743200"/>
+            <a:ext cx="11430000" cy="1143000"/>
+          </a:xfrm>
+          <a:prstGeom prst="rect">
+            <a:avLst/>
+          </a:prstGeom>
+          <a:solidFill>
+            <a:srgbClr val="F5F5F5"/>
+          </a:solidFill>
+          <a:ln>
+            <a:noFill/>
+          </a:ln>
+        </p:spPr>
+        <p:style>
+          <a:lnRef idx="1">
+            <a:schemeClr val="accent1"/>
+          </a:lnRef>
+          <a:fillRef idx="3">
+            <a:schemeClr val="accent1"/>
+          </a:fillRef>
+          <a:effectRef idx="2">
+            <a:schemeClr val="accent1"/>
+          </a:effectRef>
+          <a:fontRef idx="minor">
+            <a:schemeClr val="lt1"/>
+          </a:fontRef>
+        </p:style>
+        <p:txBody>
+          <a:bodyPr rtlCol="0" anchor="ctr"/>
+          <a:lstStyle/>
+          <a:p>
+            <a:pPr algn="ctr"/>
+          </a:p>
+        </p:txBody>
+      </p:sp>
+      <p:sp>
+        <p:nvSpPr>
+          <p:cNvPr id="7" name="TextBox 6"/>
+          <p:cNvSpPr txBox="1"/>
+          <p:nvPr/>
+        </p:nvSpPr>
+        <p:spPr>
+          <a:xfrm>
+            <a:off x="502920" y="2816352"/>
+            <a:ext cx="11155680" cy="1005840"/>
+          </a:xfrm>
+          <a:prstGeom prst="rect">
+            <a:avLst/>
+          </a:prstGeom>
+          <a:noFill/>
+        </p:spPr>
+        <p:txBody>
+          <a:bodyPr wrap="square">
+            <a:spAutoFit/>
+          </a:bodyPr>
+          <a:lstStyle/>
+          <a:p>
+            <a:pPr algn="l"/>
+            <a:r>
+              <a:rPr sz="1200" b="0">
+                <a:solidFill>
+                  <a:srgbClr val="212121"/>
+                </a:solidFill>
+              </a:rPr>
+              <a:t>[2]  T. Ochiai, K. Iwamoto, M. Delcroix et al.,
+     "Rethinking Processing Distortions: How Do They Affect the Downstream ASR Performance?"
+     IEEE/ACM Transactions on Audio, Speech, and Language Processing, TASLP 2024,
+     arXiv:2404.14860</a:t>
+            </a:r>
+          </a:p>
+        </p:txBody>
+      </p:sp>
+      <p:sp>
+        <p:nvSpPr>
+          <p:cNvPr id="8" name="Rectangle 7"/>
+          <p:cNvSpPr/>
+          <p:nvPr/>
+        </p:nvSpPr>
+        <p:spPr>
+          <a:xfrm>
+            <a:off x="365760" y="3977640"/>
+            <a:ext cx="11430000" cy="1143000"/>
+          </a:xfrm>
+          <a:prstGeom prst="rect">
+            <a:avLst/>
+          </a:prstGeom>
+          <a:solidFill>
+            <a:srgbClr val="F5F5F5"/>
+          </a:solidFill>
+          <a:ln>
+            <a:noFill/>
+          </a:ln>
+        </p:spPr>
+        <p:style>
+          <a:lnRef idx="1">
+            <a:schemeClr val="accent1"/>
+          </a:lnRef>
+          <a:fillRef idx="3">
+            <a:schemeClr val="accent1"/>
+          </a:fillRef>
+          <a:effectRef idx="2">
+            <a:schemeClr val="accent1"/>
+          </a:effectRef>
+          <a:fontRef idx="minor">
+            <a:schemeClr val="lt1"/>
+          </a:fontRef>
+        </p:style>
+        <p:txBody>
+          <a:bodyPr rtlCol="0" anchor="ctr"/>
+          <a:lstStyle/>
+          <a:p>
+            <a:pPr algn="ctr"/>
+          </a:p>
+        </p:txBody>
+      </p:sp>
+      <p:sp>
+        <p:nvSpPr>
+          <p:cNvPr id="9" name="TextBox 8"/>
+          <p:cNvSpPr txBox="1"/>
+          <p:nvPr/>
+        </p:nvSpPr>
+        <p:spPr>
+          <a:xfrm>
+            <a:off x="502920" y="4050792"/>
+            <a:ext cx="11155680" cy="1005840"/>
+          </a:xfrm>
+          <a:prstGeom prst="rect">
+            <a:avLst/>
+          </a:prstGeom>
+          <a:noFill/>
+        </p:spPr>
+        <p:txBody>
+          <a:bodyPr wrap="square">
+            <a:spAutoFit/>
+          </a:bodyPr>
+          <a:lstStyle/>
+          <a:p>
+            <a:pPr algn="l"/>
+            <a:r>
+              <a:rPr sz="1200" b="0">
+                <a:solidFill>
+                  <a:srgbClr val="212121"/>
+                </a:solidFill>
+              </a:rPr>
+              <a:t>[3]  X. Rong, C. Li, J. Xiao,
+     "GTCRN: A Speech Enhancement Model Requiring Ultra-Tiny Resources"
+     arXiv:2404.11567, 2024</a:t>
+            </a:r>
+          </a:p>
+        </p:txBody>
+      </p:sp>
+      <p:sp>
+        <p:nvSpPr>
+          <p:cNvPr id="10" name="Rectangle 9"/>
+          <p:cNvSpPr/>
+          <p:nvPr/>
+        </p:nvSpPr>
+        <p:spPr>
+          <a:xfrm>
+            <a:off x="365760" y="5212080"/>
+            <a:ext cx="11430000" cy="1143000"/>
+          </a:xfrm>
+          <a:prstGeom prst="rect">
+            <a:avLst/>
+          </a:prstGeom>
+          <a:solidFill>
+            <a:srgbClr val="F5F5F5"/>
+          </a:solidFill>
+          <a:ln>
+            <a:noFill/>
+          </a:ln>
+        </p:spPr>
+        <p:style>
+          <a:lnRef idx="1">
+            <a:schemeClr val="accent1"/>
+          </a:lnRef>
+          <a:fillRef idx="3">
+            <a:schemeClr val="accent1"/>
+          </a:fillRef>
+          <a:effectRef idx="2">
+            <a:schemeClr val="accent1"/>
+          </a:effectRef>
+          <a:fontRef idx="minor">
+            <a:schemeClr val="lt1"/>
+          </a:fontRef>
+        </p:style>
+        <p:txBody>
+          <a:bodyPr rtlCol="0" anchor="ctr"/>
+          <a:lstStyle/>
+          <a:p>
+            <a:pPr algn="ctr"/>
+          </a:p>
+        </p:txBody>
+      </p:sp>
+      <p:sp>
+        <p:nvSpPr>
+          <p:cNvPr id="11" name="TextBox 10"/>
+          <p:cNvSpPr txBox="1"/>
+          <p:nvPr/>
+        </p:nvSpPr>
+        <p:spPr>
+          <a:xfrm>
+            <a:off x="502920" y="5285232"/>
+            <a:ext cx="11155680" cy="1005840"/>
+          </a:xfrm>
+          <a:prstGeom prst="rect">
+            <a:avLst/>
+          </a:prstGeom>
+          <a:noFill/>
+        </p:spPr>
+        <p:txBody>
+          <a:bodyPr wrap="square">
+            <a:spAutoFit/>
+          </a:bodyPr>
+          <a:lstStyle/>
+          <a:p>
+            <a:pPr algn="l"/>
+            <a:r>
+              <a:rPr sz="1200" b="0">
+                <a:solidFill>
+                  <a:srgbClr val="212121"/>
+                </a:solidFill>
+              </a:rPr>
+              <a:t>[4]  Y. Kim et al.,
+     "TAPS: Throat and Acoustic Pairing Speech Dataset"
+     HuggingFace: yskim3271/Throat_and_Acoustic_Pairing_Speech_Dataset</a:t>
+            </a:r>
+          </a:p>
+        </p:txBody>
+      </p:sp>
+      <p:sp>
+        <p:nvSpPr>
+          <p:cNvPr id="12" name="Rectangle 11"/>
+          <p:cNvSpPr/>
+          <p:nvPr/>
+        </p:nvSpPr>
+        <p:spPr>
+          <a:xfrm>
+            <a:off x="0" y="6537960"/>
+            <a:ext cx="12188952" cy="320040"/>
+          </a:xfrm>
+          <a:prstGeom prst="rect">
+            <a:avLst/>
+          </a:prstGeom>
+          <a:solidFill>
+            <a:srgbClr val="E8EAF6"/>
+          </a:solidFill>
+          <a:ln>
+            <a:noFill/>
+          </a:ln>
+        </p:spPr>
+        <p:style>
+          <a:lnRef idx="1">
+            <a:schemeClr val="accent1"/>
+          </a:lnRef>
+          <a:fillRef idx="3">
+            <a:schemeClr val="accent1"/>
+          </a:fillRef>
+          <a:effectRef idx="2">
+            <a:schemeClr val="accent1"/>
+          </a:effectRef>
+          <a:fontRef idx="minor">
+            <a:schemeClr val="lt1"/>
+          </a:fontRef>
+        </p:style>
+        <p:txBody>
+          <a:bodyPr rtlCol="0" anchor="ctr"/>
+          <a:lstStyle/>
+          <a:p>
+            <a:pPr algn="ctr"/>
+          </a:p>
+        </p:txBody>
+      </p:sp>
+      <p:sp>
+        <p:nvSpPr>
+          <p:cNvPr id="13" name="TextBox 12"/>
+          <p:cNvSpPr txBox="1"/>
+          <p:nvPr/>
+        </p:nvSpPr>
+        <p:spPr>
+          <a:xfrm>
+            <a:off x="11091672" y="6565392"/>
+            <a:ext cx="1005840" cy="274320"/>
+          </a:xfrm>
+          <a:prstGeom prst="rect">
+            <a:avLst/>
+          </a:prstGeom>
+          <a:noFill/>
+        </p:spPr>
+        <p:txBody>
+          <a:bodyPr wrap="square">
+            <a:spAutoFit/>
+          </a:bodyPr>
+          <a:lstStyle/>
+          <a:p>
+            <a:pPr algn="r"/>
+            <a:r>
+              <a:rPr sz="1000" b="0">
+                <a:solidFill>
+                  <a:srgbClr val="1A237E"/>
+                </a:solidFill>
+              </a:rPr>
+              <a:t>27 / 28</a:t>
+            </a:r>
+          </a:p>
+        </p:txBody>
+      </p:sp>
+    </p:spTree>
+  </p:cSld>
+  <p:clrMapOvr>
+    <a:masterClrMapping/>
+  </p:clrMapOvr>
+</p:sld>
+</file>
+
+<file path=ppt/slides/slide28.xml><?xml version="1.0" encoding="utf-8"?>
+<p:sld xmlns:a="http://schemas.openxmlformats.org/drawingml/2006/main" xmlns:p="http://schemas.openxmlformats.org/presentationml/2006/main" xmlns:r="http://schemas.openxmlformats.org/officeDocument/2006/relationships">
+  <p:cSld>
+    <p:spTree>
+      <p:nvGrpSpPr>
+        <p:cNvPr id="1" name=""/>
+        <p:cNvGrpSpPr/>
+        <p:nvPr/>
+      </p:nvGrpSpPr>
+      <p:grpSpPr/>
+      <p:sp>
+        <p:nvSpPr>
+          <p:cNvPr id="2" name="Rectangle 1"/>
+          <p:cNvSpPr/>
+          <p:nvPr/>
+        </p:nvSpPr>
+        <p:spPr>
+          <a:xfrm>
+            <a:off x="0" y="0"/>
+            <a:ext cx="12188952" cy="6858000"/>
+          </a:xfrm>
+          <a:prstGeom prst="rect">
+            <a:avLst/>
+          </a:prstGeom>
+          <a:solidFill>
+            <a:srgbClr val="1A237E"/>
+          </a:solidFill>
+          <a:ln>
+            <a:noFill/>
+          </a:ln>
+        </p:spPr>
+        <p:style>
+          <a:lnRef idx="1">
+            <a:schemeClr val="accent1"/>
+          </a:lnRef>
+          <a:fillRef idx="3">
+            <a:schemeClr val="accent1"/>
+          </a:fillRef>
+          <a:effectRef idx="2">
+            <a:schemeClr val="accent1"/>
+          </a:effectRef>
+          <a:fontRef idx="minor">
+            <a:schemeClr val="lt1"/>
+          </a:fontRef>
+        </p:style>
+        <p:txBody>
+          <a:bodyPr rtlCol="0" anchor="ctr"/>
+          <a:lstStyle/>
+          <a:p>
+            <a:pPr algn="ctr"/>
+          </a:p>
+        </p:txBody>
+      </p:sp>
+      <p:sp>
+        <p:nvSpPr>
           <p:cNvPr id="3" name="Rectangle 2"/>
           <p:cNvSpPr/>
           <p:nvPr/>
@@ -17677,7 +18833,7 @@
                   <a:srgbClr val="1A237E"/>
                 </a:solidFill>
               </a:rPr>
-              <a:t>27 / 25</a:t>
+              <a:t>28 / 28</a:t>
             </a:r>
           </a:p>
         </p:txBody>
@@ -18531,7 +19687,7 @@
                   <a:srgbClr val="1A237E"/>
                 </a:solidFill>
               </a:rPr>
-              <a:t>3 / 25</a:t>
+              <a:t>3 / 28</a:t>
             </a:r>
           </a:p>
         </p:txBody>
@@ -19721,7 +20877,7 @@
                   <a:srgbClr val="1A237E"/>
                 </a:solidFill>
               </a:rPr>
-              <a:t>4 / 25</a:t>
+              <a:t>4 / 28</a:t>
             </a:r>
           </a:p>
         </p:txBody>
@@ -20273,7 +21429,7 @@
                   <a:srgbClr val="1A237E"/>
                 </a:solidFill>
               </a:rPr>
-              <a:t>5 / 25</a:t>
+              <a:t>5 / 28</a:t>
             </a:r>
           </a:p>
         </p:txBody>
@@ -21006,7 +22162,7 @@
                   <a:srgbClr val="1A237E"/>
                 </a:solidFill>
               </a:rPr>
-              <a:t>6 / 25</a:t>
+              <a:t>6 / 28</a:t>
             </a:r>
           </a:p>
         </p:txBody>
@@ -21701,7 +22857,7 @@
                   <a:srgbClr val="1A237E"/>
                 </a:solidFill>
               </a:rPr>
-              <a:t>7 / 25</a:t>
+              <a:t>7 / 28</a:t>
             </a:r>
           </a:p>
         </p:txBody>
@@ -22696,7 +23852,7 @@
                   <a:srgbClr val="1A237E"/>
                 </a:solidFill>
               </a:rPr>
-              <a:t>8 / 25</a:t>
+              <a:t>8 / 28</a:t>
             </a:r>
           </a:p>
         </p:txBody>
@@ -23554,7 +24710,7 @@
                   <a:srgbClr val="1A237E"/>
                 </a:solidFill>
               </a:rPr>
-              <a:t>9 / 25</a:t>
+              <a:t>9 / 28</a:t>
             </a:r>
           </a:p>
         </p:txBody>

</xml_diff>